<commit_message>
Material pratico 2 - LP
</commit_message>
<xml_diff>
--- a/UNIUBE-LP/Teoria_LP.pptx
+++ b/UNIUBE-LP/Teoria_LP.pptx
@@ -19542,8 +19542,8 @@
           </a:p>
         </p:txBody>
       </p:sp>
-      <mc:AlternateContent xmlns:mc="http://schemas.openxmlformats.org/markup-compatibility/2006">
-        <mc:Choice xmlns:a14="http://schemas.microsoft.com/office/drawing/2010/main" Requires="a14">
+      <mc:AlternateContent xmlns:mc="http://schemas.openxmlformats.org/markup-compatibility/2006" xmlns:a14="http://schemas.microsoft.com/office/drawing/2010/main">
+        <mc:Choice Requires="a14">
           <p:sp>
             <p:nvSpPr>
               <p:cNvPr id="6" name="Espaço Reservado para Conteúdo 5">
@@ -19744,7 +19744,7 @@
             </p:txBody>
           </p:sp>
         </mc:Choice>
-        <mc:Fallback>
+        <mc:Fallback xmlns="">
           <p:sp>
             <p:nvSpPr>
               <p:cNvPr id="6" name="Espaço Reservado para Conteúdo 5">

</xml_diff>

<commit_message>
Correção do conteúdo de LP
</commit_message>
<xml_diff>
--- a/UNIUBE-LP/Teoria_LP.pptx
+++ b/UNIUBE-LP/Teoria_LP.pptx
@@ -240,7 +240,7 @@
           <a:p>
             <a:fld id="{6ED03497-8374-466E-85FA-95E1138D8F6E}" type="datetimeFigureOut">
               <a:rPr lang="pt-BR" smtClean="0"/>
-              <a:t>05/08/2026</a:t>
+              <a:t>10/08/2026</a:t>
             </a:fld>
             <a:endParaRPr lang="pt-BR"/>
           </a:p>
@@ -9775,7 +9775,7 @@
           <a:p>
             <a:fld id="{A87E3B6E-8316-4A1C-BADA-DB7F3456EEF1}" type="datetimeFigureOut">
               <a:rPr lang="pt-BR" smtClean="0"/>
-              <a:t>05/08/2026</a:t>
+              <a:t>10/08/2026</a:t>
             </a:fld>
             <a:endParaRPr lang="pt-BR"/>
           </a:p>
@@ -9973,7 +9973,7 @@
           <a:p>
             <a:fld id="{A87E3B6E-8316-4A1C-BADA-DB7F3456EEF1}" type="datetimeFigureOut">
               <a:rPr lang="pt-BR" smtClean="0"/>
-              <a:t>05/08/2026</a:t>
+              <a:t>10/08/2026</a:t>
             </a:fld>
             <a:endParaRPr lang="pt-BR"/>
           </a:p>
@@ -10181,7 +10181,7 @@
           <a:p>
             <a:fld id="{A87E3B6E-8316-4A1C-BADA-DB7F3456EEF1}" type="datetimeFigureOut">
               <a:rPr lang="pt-BR" smtClean="0"/>
-              <a:t>05/08/2026</a:t>
+              <a:t>10/08/2026</a:t>
             </a:fld>
             <a:endParaRPr lang="pt-BR"/>
           </a:p>
@@ -10417,7 +10417,7 @@
           <a:p>
             <a:fld id="{A87E3B6E-8316-4A1C-BADA-DB7F3456EEF1}" type="datetimeFigureOut">
               <a:rPr lang="pt-BR" smtClean="0"/>
-              <a:t>05/08/2026</a:t>
+              <a:t>10/08/2026</a:t>
             </a:fld>
             <a:endParaRPr lang="pt-BR"/>
           </a:p>
@@ -10587,7 +10587,7 @@
           <a:p>
             <a:fld id="{A87E3B6E-8316-4A1C-BADA-DB7F3456EEF1}" type="datetimeFigureOut">
               <a:rPr lang="pt-BR" smtClean="0"/>
-              <a:t>05/08/2026</a:t>
+              <a:t>10/08/2026</a:t>
             </a:fld>
             <a:endParaRPr lang="pt-BR"/>
           </a:p>
@@ -10855,7 +10855,7 @@
           <a:p>
             <a:fld id="{A87E3B6E-8316-4A1C-BADA-DB7F3456EEF1}" type="datetimeFigureOut">
               <a:rPr lang="pt-BR" smtClean="0"/>
-              <a:t>05/08/2026</a:t>
+              <a:t>10/08/2026</a:t>
             </a:fld>
             <a:endParaRPr lang="pt-BR"/>
           </a:p>
@@ -11087,7 +11087,7 @@
           <a:p>
             <a:fld id="{A87E3B6E-8316-4A1C-BADA-DB7F3456EEF1}" type="datetimeFigureOut">
               <a:rPr lang="pt-BR" smtClean="0"/>
-              <a:t>05/08/2026</a:t>
+              <a:t>10/08/2026</a:t>
             </a:fld>
             <a:endParaRPr lang="pt-BR"/>
           </a:p>
@@ -11442,7 +11442,7 @@
           <a:p>
             <a:fld id="{A87E3B6E-8316-4A1C-BADA-DB7F3456EEF1}" type="datetimeFigureOut">
               <a:rPr lang="pt-BR" smtClean="0"/>
-              <a:t>05/08/2026</a:t>
+              <a:t>10/08/2026</a:t>
             </a:fld>
             <a:endParaRPr lang="pt-BR"/>
           </a:p>
@@ -11583,7 +11583,7 @@
           <a:p>
             <a:fld id="{A87E3B6E-8316-4A1C-BADA-DB7F3456EEF1}" type="datetimeFigureOut">
               <a:rPr lang="pt-BR" smtClean="0"/>
-              <a:t>05/08/2026</a:t>
+              <a:t>10/08/2026</a:t>
             </a:fld>
             <a:endParaRPr lang="pt-BR"/>
           </a:p>
@@ -11678,7 +11678,7 @@
           <a:p>
             <a:fld id="{A87E3B6E-8316-4A1C-BADA-DB7F3456EEF1}" type="datetimeFigureOut">
               <a:rPr lang="pt-BR" smtClean="0"/>
-              <a:t>05/08/2026</a:t>
+              <a:t>10/08/2026</a:t>
             </a:fld>
             <a:endParaRPr lang="pt-BR"/>
           </a:p>
@@ -12035,7 +12035,7 @@
           <a:p>
             <a:fld id="{A87E3B6E-8316-4A1C-BADA-DB7F3456EEF1}" type="datetimeFigureOut">
               <a:rPr lang="pt-BR" smtClean="0"/>
-              <a:t>05/08/2026</a:t>
+              <a:t>10/08/2026</a:t>
             </a:fld>
             <a:endParaRPr lang="pt-BR"/>
           </a:p>
@@ -12236,7 +12236,7 @@
           <a:p>
             <a:fld id="{A87E3B6E-8316-4A1C-BADA-DB7F3456EEF1}" type="datetimeFigureOut">
               <a:rPr lang="pt-BR" smtClean="0"/>
-              <a:t>05/08/2026</a:t>
+              <a:t>10/08/2026</a:t>
             </a:fld>
             <a:endParaRPr lang="pt-BR"/>
           </a:p>
@@ -12589,7 +12589,7 @@
           <a:p>
             <a:fld id="{A87E3B6E-8316-4A1C-BADA-DB7F3456EEF1}" type="datetimeFigureOut">
               <a:rPr lang="pt-BR" smtClean="0"/>
-              <a:t>05/08/2026</a:t>
+              <a:t>10/08/2026</a:t>
             </a:fld>
             <a:endParaRPr lang="pt-BR"/>
           </a:p>
@@ -12774,7 +12774,7 @@
           <a:p>
             <a:fld id="{A87E3B6E-8316-4A1C-BADA-DB7F3456EEF1}" type="datetimeFigureOut">
               <a:rPr lang="pt-BR" smtClean="0"/>
-              <a:t>05/08/2026</a:t>
+              <a:t>10/08/2026</a:t>
             </a:fld>
             <a:endParaRPr lang="pt-BR"/>
           </a:p>
@@ -12954,7 +12954,7 @@
           <a:p>
             <a:fld id="{A87E3B6E-8316-4A1C-BADA-DB7F3456EEF1}" type="datetimeFigureOut">
               <a:rPr lang="pt-BR" smtClean="0"/>
-              <a:t>05/08/2026</a:t>
+              <a:t>10/08/2026</a:t>
             </a:fld>
             <a:endParaRPr lang="pt-BR"/>
           </a:p>
@@ -13217,7 +13217,7 @@
           <a:p>
             <a:fld id="{A87E3B6E-8316-4A1C-BADA-DB7F3456EEF1}" type="datetimeFigureOut">
               <a:rPr lang="pt-BR" smtClean="0"/>
-              <a:t>05/08/2026</a:t>
+              <a:t>10/08/2026</a:t>
             </a:fld>
             <a:endParaRPr lang="pt-BR"/>
           </a:p>
@@ -13482,7 +13482,7 @@
           <a:p>
             <a:fld id="{A87E3B6E-8316-4A1C-BADA-DB7F3456EEF1}" type="datetimeFigureOut">
               <a:rPr lang="pt-BR" smtClean="0"/>
-              <a:t>05/08/2026</a:t>
+              <a:t>10/08/2026</a:t>
             </a:fld>
             <a:endParaRPr lang="pt-BR"/>
           </a:p>
@@ -13894,7 +13894,7 @@
           <a:p>
             <a:fld id="{A87E3B6E-8316-4A1C-BADA-DB7F3456EEF1}" type="datetimeFigureOut">
               <a:rPr lang="pt-BR" smtClean="0"/>
-              <a:t>05/08/2026</a:t>
+              <a:t>10/08/2026</a:t>
             </a:fld>
             <a:endParaRPr lang="pt-BR"/>
           </a:p>
@@ -14035,7 +14035,7 @@
           <a:p>
             <a:fld id="{A87E3B6E-8316-4A1C-BADA-DB7F3456EEF1}" type="datetimeFigureOut">
               <a:rPr lang="pt-BR" smtClean="0"/>
-              <a:t>05/08/2026</a:t>
+              <a:t>10/08/2026</a:t>
             </a:fld>
             <a:endParaRPr lang="pt-BR"/>
           </a:p>
@@ -14148,7 +14148,7 @@
           <a:p>
             <a:fld id="{A87E3B6E-8316-4A1C-BADA-DB7F3456EEF1}" type="datetimeFigureOut">
               <a:rPr lang="pt-BR" smtClean="0"/>
-              <a:t>05/08/2026</a:t>
+              <a:t>10/08/2026</a:t>
             </a:fld>
             <a:endParaRPr lang="pt-BR"/>
           </a:p>
@@ -14459,7 +14459,7 @@
           <a:p>
             <a:fld id="{A87E3B6E-8316-4A1C-BADA-DB7F3456EEF1}" type="datetimeFigureOut">
               <a:rPr lang="pt-BR" smtClean="0"/>
-              <a:t>05/08/2026</a:t>
+              <a:t>10/08/2026</a:t>
             </a:fld>
             <a:endParaRPr lang="pt-BR"/>
           </a:p>
@@ -14747,7 +14747,7 @@
           <a:p>
             <a:fld id="{A87E3B6E-8316-4A1C-BADA-DB7F3456EEF1}" type="datetimeFigureOut">
               <a:rPr lang="pt-BR" smtClean="0"/>
-              <a:t>05/08/2026</a:t>
+              <a:t>10/08/2026</a:t>
             </a:fld>
             <a:endParaRPr lang="pt-BR"/>
           </a:p>
@@ -14988,7 +14988,7 @@
           <a:p>
             <a:fld id="{A87E3B6E-8316-4A1C-BADA-DB7F3456EEF1}" type="datetimeFigureOut">
               <a:rPr lang="pt-BR" smtClean="0"/>
-              <a:t>05/08/2026</a:t>
+              <a:t>10/08/2026</a:t>
             </a:fld>
             <a:endParaRPr lang="pt-BR"/>
           </a:p>
@@ -15552,7 +15552,7 @@
           <a:p>
             <a:fld id="{A87E3B6E-8316-4A1C-BADA-DB7F3456EEF1}" type="datetimeFigureOut">
               <a:rPr lang="pt-BR" smtClean="0"/>
-              <a:t>05/08/2026</a:t>
+              <a:t>10/08/2026</a:t>
             </a:fld>
             <a:endParaRPr lang="pt-BR"/>
           </a:p>
@@ -27087,8 +27087,8 @@
           </a:p>
         </p:txBody>
       </p:sp>
-      <mc:AlternateContent xmlns:mc="http://schemas.openxmlformats.org/markup-compatibility/2006">
-        <mc:Choice xmlns:a14="http://schemas.microsoft.com/office/drawing/2010/main" Requires="a14">
+      <mc:AlternateContent xmlns:mc="http://schemas.openxmlformats.org/markup-compatibility/2006" xmlns:a14="http://schemas.microsoft.com/office/drawing/2010/main">
+        <mc:Choice Requires="a14">
           <p:sp>
             <p:nvSpPr>
               <p:cNvPr id="6" name="Espaço Reservado para Conteúdo 5">
@@ -27379,7 +27379,7 @@
             </p:txBody>
           </p:sp>
         </mc:Choice>
-        <mc:Fallback>
+        <mc:Fallback xmlns="">
           <p:sp>
             <p:nvSpPr>
               <p:cNvPr id="6" name="Espaço Reservado para Conteúdo 5">
@@ -28030,12 +28030,8 @@
               <a:buAutoNum type="arabicPeriod"/>
             </a:pPr>
             <a:r>
-              <a:rPr lang="pt-BR" sz="2600" dirty="0"/>
-              <a:t>Também é permitido fazer casting entre </a:t>
-            </a:r>
-            <a:r>
               <a:rPr lang="pt-BR" sz="2400" dirty="0"/>
-              <a:t>Ponteiros como:</a:t>
+              <a:t>Também é permitido fazer casting entre Ponteiros como:</a:t>
             </a:r>
           </a:p>
           <a:p>
@@ -28068,15 +28064,7 @@
             </a:r>
             <a:r>
               <a:rPr lang="pt-BR" sz="2200" dirty="0"/>
-              <a:t>  (</a:t>
-            </a:r>
-            <a:r>
-              <a:rPr lang="pt-BR" sz="2200" dirty="0" err="1"/>
-              <a:t>exije</a:t>
-            </a:r>
-            <a:r>
-              <a:rPr lang="pt-BR" sz="2200" dirty="0"/>
-              <a:t> cuidado para evitar erros de acesso à memória)</a:t>
+              <a:t>  (exige cuidado para evitar erros de acesso à memória)</a:t>
             </a:r>
           </a:p>
           <a:p>
@@ -28092,23 +28080,23 @@
               <a:buAutoNum type="arabicPeriod"/>
             </a:pPr>
             <a:r>
-              <a:rPr lang="pt-BR" sz="2600" dirty="0"/>
+              <a:rPr lang="pt-BR" sz="2400" dirty="0"/>
               <a:t>Não é permitido o casting entre tipos primitivos e tipos complexos (como o </a:t>
             </a:r>
             <a:r>
-              <a:rPr lang="pt-BR" sz="2600" dirty="0" err="1"/>
+              <a:rPr lang="pt-BR" sz="2400" dirty="0" err="1"/>
               <a:t>struct</a:t>
             </a:r>
             <a:r>
-              <a:rPr lang="pt-BR" sz="2600" dirty="0"/>
+              <a:rPr lang="pt-BR" sz="2400" dirty="0"/>
               <a:t>), nem a conversão de </a:t>
             </a:r>
             <a:r>
-              <a:rPr lang="pt-BR" sz="2600" dirty="0" err="1"/>
+              <a:rPr lang="pt-BR" sz="2400" dirty="0" err="1"/>
               <a:t>strings</a:t>
             </a:r>
             <a:r>
-              <a:rPr lang="pt-BR" sz="2600" dirty="0"/>
+              <a:rPr lang="pt-BR" sz="2400" dirty="0"/>
               <a:t>  para valores numéricos </a:t>
             </a:r>
           </a:p>

</xml_diff>

<commit_message>
Atualização de aulas de LP2 13/08
</commit_message>
<xml_diff>
--- a/UNIUBE-LP/Teoria_LP.pptx
+++ b/UNIUBE-LP/Teoria_LP.pptx
@@ -6,7 +6,7 @@
     <p:sldMasterId id="2147483684" r:id="rId2"/>
   </p:sldMasterIdLst>
   <p:notesMasterIdLst>
-    <p:notesMasterId r:id="rId57"/>
+    <p:notesMasterId r:id="rId56"/>
   </p:notesMasterIdLst>
   <p:sldIdLst>
     <p:sldId id="256" r:id="rId3"/>
@@ -54,15 +54,14 @@
     <p:sldId id="310" r:id="rId45"/>
     <p:sldId id="311" r:id="rId46"/>
     <p:sldId id="312" r:id="rId47"/>
-    <p:sldId id="314" r:id="rId48"/>
-    <p:sldId id="313" r:id="rId49"/>
-    <p:sldId id="316" r:id="rId50"/>
-    <p:sldId id="315" r:id="rId51"/>
-    <p:sldId id="319" r:id="rId52"/>
-    <p:sldId id="317" r:id="rId53"/>
-    <p:sldId id="320" r:id="rId54"/>
-    <p:sldId id="318" r:id="rId55"/>
-    <p:sldId id="321" r:id="rId56"/>
+    <p:sldId id="313" r:id="rId48"/>
+    <p:sldId id="316" r:id="rId49"/>
+    <p:sldId id="315" r:id="rId50"/>
+    <p:sldId id="319" r:id="rId51"/>
+    <p:sldId id="317" r:id="rId52"/>
+    <p:sldId id="320" r:id="rId53"/>
+    <p:sldId id="318" r:id="rId54"/>
+    <p:sldId id="321" r:id="rId55"/>
   </p:sldIdLst>
   <p:sldSz cx="12192000" cy="6858000"/>
   <p:notesSz cx="6858000" cy="9144000"/>
@@ -8519,153 +8518,6 @@
         <p:cNvPr id="1" name="">
           <a:extLst>
             <a:ext uri="{FF2B5EF4-FFF2-40B4-BE49-F238E27FC236}">
-              <a16:creationId xmlns:a16="http://schemas.microsoft.com/office/drawing/2014/main" id="{EBA41F87-106A-8328-8861-88768D8175AA}"/>
-            </a:ext>
-          </a:extLst>
-        </p:cNvPr>
-        <p:cNvGrpSpPr/>
-        <p:nvPr/>
-      </p:nvGrpSpPr>
-      <p:grpSpPr>
-        <a:xfrm>
-          <a:off x="0" y="0"/>
-          <a:ext cx="0" cy="0"/>
-          <a:chOff x="0" y="0"/>
-          <a:chExt cx="0" cy="0"/>
-        </a:xfrm>
-      </p:grpSpPr>
-      <p:sp>
-        <p:nvSpPr>
-          <p:cNvPr id="2" name="Espaço Reservado para Imagem de Slide 1">
-            <a:extLst>
-              <a:ext uri="{FF2B5EF4-FFF2-40B4-BE49-F238E27FC236}">
-                <a16:creationId xmlns:a16="http://schemas.microsoft.com/office/drawing/2014/main" id="{B938D9B5-420E-638D-EB91-26BCDB028281}"/>
-              </a:ext>
-            </a:extLst>
-          </p:cNvPr>
-          <p:cNvSpPr>
-            <a:spLocks noGrp="1" noRot="1" noChangeAspect="1"/>
-          </p:cNvSpPr>
-          <p:nvPr>
-            <p:ph type="sldImg"/>
-          </p:nvPr>
-        </p:nvSpPr>
-        <p:spPr/>
-      </p:sp>
-      <p:sp>
-        <p:nvSpPr>
-          <p:cNvPr id="3" name="Espaço Reservado para Anotações 2">
-            <a:extLst>
-              <a:ext uri="{FF2B5EF4-FFF2-40B4-BE49-F238E27FC236}">
-                <a16:creationId xmlns:a16="http://schemas.microsoft.com/office/drawing/2014/main" id="{42979F52-83AF-F822-9579-854129FB8F59}"/>
-              </a:ext>
-            </a:extLst>
-          </p:cNvPr>
-          <p:cNvSpPr>
-            <a:spLocks noGrp="1"/>
-          </p:cNvSpPr>
-          <p:nvPr>
-            <p:ph type="body" idx="1"/>
-          </p:nvPr>
-        </p:nvSpPr>
-        <p:spPr/>
-        <p:txBody>
-          <a:bodyPr/>
-          <a:lstStyle/>
-          <a:p>
-            <a:pPr marL="171450" indent="-171450">
-              <a:buFont typeface="Arial" panose="020B0604020202020204" pitchFamily="34" charset="0"/>
-              <a:buChar char="•"/>
-            </a:pPr>
-            <a:r>
-              <a:rPr lang="pt-BR" sz="1200" b="0" kern="1200" dirty="0">
-                <a:solidFill>
-                  <a:schemeClr val="tx1"/>
-                </a:solidFill>
-                <a:effectLst/>
-                <a:latin typeface="+mn-lt"/>
-                <a:ea typeface="+mn-ea"/>
-                <a:cs typeface="+mn-cs"/>
-              </a:rPr>
-              <a:t>Observação:  </a:t>
-            </a:r>
-            <a:r>
-              <a:rPr lang="pt-BR" sz="1200" dirty="0"/>
-              <a:t>5 % 2=1</a:t>
-            </a:r>
-            <a:r>
-              <a:rPr lang="pt-BR" sz="1200" dirty="0">
-                <a:latin typeface="Calibri" panose="020F0502020204030204" pitchFamily="34" charset="0"/>
-                <a:ea typeface="Calibri" panose="020F0502020204030204" pitchFamily="34" charset="0"/>
-                <a:cs typeface="Calibri" panose="020F0502020204030204" pitchFamily="34" charset="0"/>
-              </a:rPr>
-              <a:t>  porque 2*2=4 (sobrando 1)</a:t>
-            </a:r>
-            <a:r>
-              <a:rPr lang="pt-BR" sz="1200" b="0" kern="1200" dirty="0">
-                <a:solidFill>
-                  <a:schemeClr val="tx1"/>
-                </a:solidFill>
-                <a:effectLst/>
-                <a:latin typeface="+mn-lt"/>
-                <a:ea typeface="+mn-ea"/>
-                <a:cs typeface="+mn-cs"/>
-              </a:rPr>
-              <a:t> </a:t>
-            </a:r>
-          </a:p>
-        </p:txBody>
-      </p:sp>
-      <p:sp>
-        <p:nvSpPr>
-          <p:cNvPr id="4" name="Espaço Reservado para Número de Slide 3">
-            <a:extLst>
-              <a:ext uri="{FF2B5EF4-FFF2-40B4-BE49-F238E27FC236}">
-                <a16:creationId xmlns:a16="http://schemas.microsoft.com/office/drawing/2014/main" id="{EB709A17-C652-CF3A-1C16-828CA83A71AB}"/>
-              </a:ext>
-            </a:extLst>
-          </p:cNvPr>
-          <p:cNvSpPr>
-            <a:spLocks noGrp="1"/>
-          </p:cNvSpPr>
-          <p:nvPr>
-            <p:ph type="sldNum" sz="quarter" idx="5"/>
-          </p:nvPr>
-        </p:nvSpPr>
-        <p:spPr/>
-        <p:txBody>
-          <a:bodyPr/>
-          <a:lstStyle/>
-          <a:p>
-            <a:fld id="{80F36A49-A1DD-40F8-B8AD-E6F5365256CB}" type="slidenum">
-              <a:rPr lang="pt-BR" smtClean="0"/>
-              <a:t>46</a:t>
-            </a:fld>
-            <a:endParaRPr lang="pt-BR"/>
-          </a:p>
-        </p:txBody>
-      </p:sp>
-    </p:spTree>
-    <p:extLst>
-      <p:ext uri="{BB962C8B-B14F-4D97-AF65-F5344CB8AC3E}">
-        <p14:creationId xmlns:p14="http://schemas.microsoft.com/office/powerpoint/2010/main" val="3036492755"/>
-      </p:ext>
-    </p:extLst>
-  </p:cSld>
-  <p:clrMapOvr>
-    <a:masterClrMapping/>
-  </p:clrMapOvr>
-</p:notes>
-</file>
-
-<file path=ppt/notesSlides/notesSlide45.xml><?xml version="1.0" encoding="utf-8"?>
-<p:notes xmlns:a="http://schemas.openxmlformats.org/drawingml/2006/main" xmlns:r="http://schemas.openxmlformats.org/officeDocument/2006/relationships" xmlns:p="http://schemas.openxmlformats.org/presentationml/2006/main">
-  <p:cSld>
-    <p:spTree>
-      <p:nvGrpSpPr>
-        <p:cNvPr id="1" name="">
-          <a:extLst>
-            <a:ext uri="{FF2B5EF4-FFF2-40B4-BE49-F238E27FC236}">
               <a16:creationId xmlns:a16="http://schemas.microsoft.com/office/drawing/2014/main" id="{5B75D978-E0E2-5129-3B2C-00F642E08BE6}"/>
             </a:ext>
           </a:extLst>
@@ -8786,7 +8638,7 @@
           <a:p>
             <a:fld id="{80F36A49-A1DD-40F8-B8AD-E6F5365256CB}" type="slidenum">
               <a:rPr lang="pt-BR" smtClean="0"/>
-              <a:t>48</a:t>
+              <a:t>47</a:t>
             </a:fld>
             <a:endParaRPr lang="pt-BR"/>
           </a:p>
@@ -8805,7 +8657,7 @@
 </p:notes>
 </file>
 
-<file path=ppt/notesSlides/notesSlide46.xml><?xml version="1.0" encoding="utf-8"?>
+<file path=ppt/notesSlides/notesSlide45.xml><?xml version="1.0" encoding="utf-8"?>
 <p:notes xmlns:a="http://schemas.openxmlformats.org/drawingml/2006/main" xmlns:r="http://schemas.openxmlformats.org/officeDocument/2006/relationships" xmlns:p="http://schemas.openxmlformats.org/presentationml/2006/main">
   <p:cSld>
     <p:spTree>
@@ -8933,7 +8785,7 @@
           <a:p>
             <a:fld id="{80F36A49-A1DD-40F8-B8AD-E6F5365256CB}" type="slidenum">
               <a:rPr lang="pt-BR" smtClean="0"/>
-              <a:t>49</a:t>
+              <a:t>48</a:t>
             </a:fld>
             <a:endParaRPr lang="pt-BR"/>
           </a:p>
@@ -8952,7 +8804,7 @@
 </p:notes>
 </file>
 
-<file path=ppt/notesSlides/notesSlide47.xml><?xml version="1.0" encoding="utf-8"?>
+<file path=ppt/notesSlides/notesSlide46.xml><?xml version="1.0" encoding="utf-8"?>
 <p:notes xmlns:a="http://schemas.openxmlformats.org/drawingml/2006/main" xmlns:r="http://schemas.openxmlformats.org/officeDocument/2006/relationships" xmlns:p="http://schemas.openxmlformats.org/presentationml/2006/main">
   <p:cSld>
     <p:spTree>
@@ -9080,7 +8932,7 @@
           <a:p>
             <a:fld id="{80F36A49-A1DD-40F8-B8AD-E6F5365256CB}" type="slidenum">
               <a:rPr lang="pt-BR" smtClean="0"/>
-              <a:t>50</a:t>
+              <a:t>49</a:t>
             </a:fld>
             <a:endParaRPr lang="pt-BR"/>
           </a:p>
@@ -9099,7 +8951,7 @@
 </p:notes>
 </file>
 
-<file path=ppt/notesSlides/notesSlide48.xml><?xml version="1.0" encoding="utf-8"?>
+<file path=ppt/notesSlides/notesSlide47.xml><?xml version="1.0" encoding="utf-8"?>
 <p:notes xmlns:a="http://schemas.openxmlformats.org/drawingml/2006/main" xmlns:r="http://schemas.openxmlformats.org/officeDocument/2006/relationships" xmlns:p="http://schemas.openxmlformats.org/presentationml/2006/main">
   <p:cSld>
     <p:spTree>
@@ -9227,7 +9079,7 @@
           <a:p>
             <a:fld id="{80F36A49-A1DD-40F8-B8AD-E6F5365256CB}" type="slidenum">
               <a:rPr lang="pt-BR" smtClean="0"/>
-              <a:t>51</a:t>
+              <a:t>50</a:t>
             </a:fld>
             <a:endParaRPr lang="pt-BR"/>
           </a:p>
@@ -9246,7 +9098,7 @@
 </p:notes>
 </file>
 
-<file path=ppt/notesSlides/notesSlide49.xml><?xml version="1.0" encoding="utf-8"?>
+<file path=ppt/notesSlides/notesSlide48.xml><?xml version="1.0" encoding="utf-8"?>
 <p:notes xmlns:a="http://schemas.openxmlformats.org/drawingml/2006/main" xmlns:r="http://schemas.openxmlformats.org/officeDocument/2006/relationships" xmlns:p="http://schemas.openxmlformats.org/presentationml/2006/main">
   <p:cSld>
     <p:spTree>
@@ -9374,7 +9226,7 @@
           <a:p>
             <a:fld id="{80F36A49-A1DD-40F8-B8AD-E6F5365256CB}" type="slidenum">
               <a:rPr lang="pt-BR" smtClean="0"/>
-              <a:t>52</a:t>
+              <a:t>51</a:t>
             </a:fld>
             <a:endParaRPr lang="pt-BR"/>
           </a:p>
@@ -9384,6 +9236,165 @@
     <p:extLst>
       <p:ext uri="{BB962C8B-B14F-4D97-AF65-F5344CB8AC3E}">
         <p14:creationId xmlns:p14="http://schemas.microsoft.com/office/powerpoint/2010/main" val="1355024193"/>
+      </p:ext>
+    </p:extLst>
+  </p:cSld>
+  <p:clrMapOvr>
+    <a:masterClrMapping/>
+  </p:clrMapOvr>
+</p:notes>
+</file>
+
+<file path=ppt/notesSlides/notesSlide49.xml><?xml version="1.0" encoding="utf-8"?>
+<p:notes xmlns:a="http://schemas.openxmlformats.org/drawingml/2006/main" xmlns:r="http://schemas.openxmlformats.org/officeDocument/2006/relationships" xmlns:p="http://schemas.openxmlformats.org/presentationml/2006/main">
+  <p:cSld>
+    <p:spTree>
+      <p:nvGrpSpPr>
+        <p:cNvPr id="1" name="">
+          <a:extLst>
+            <a:ext uri="{FF2B5EF4-FFF2-40B4-BE49-F238E27FC236}">
+              <a16:creationId xmlns:a16="http://schemas.microsoft.com/office/drawing/2014/main" id="{EB1E513E-2B81-48E5-AD93-5FBA5C2E5B7D}"/>
+            </a:ext>
+          </a:extLst>
+        </p:cNvPr>
+        <p:cNvGrpSpPr/>
+        <p:nvPr/>
+      </p:nvGrpSpPr>
+      <p:grpSpPr>
+        <a:xfrm>
+          <a:off x="0" y="0"/>
+          <a:ext cx="0" cy="0"/>
+          <a:chOff x="0" y="0"/>
+          <a:chExt cx="0" cy="0"/>
+        </a:xfrm>
+      </p:grpSpPr>
+      <p:sp>
+        <p:nvSpPr>
+          <p:cNvPr id="2" name="Espaço Reservado para Imagem de Slide 1">
+            <a:extLst>
+              <a:ext uri="{FF2B5EF4-FFF2-40B4-BE49-F238E27FC236}">
+                <a16:creationId xmlns:a16="http://schemas.microsoft.com/office/drawing/2014/main" id="{6002FD15-ED4B-8A4B-77A0-07E09B201A3A}"/>
+              </a:ext>
+            </a:extLst>
+          </p:cNvPr>
+          <p:cNvSpPr>
+            <a:spLocks noGrp="1" noRot="1" noChangeAspect="1"/>
+          </p:cNvSpPr>
+          <p:nvPr>
+            <p:ph type="sldImg"/>
+          </p:nvPr>
+        </p:nvSpPr>
+        <p:spPr/>
+      </p:sp>
+      <p:sp>
+        <p:nvSpPr>
+          <p:cNvPr id="3" name="Espaço Reservado para Anotações 2">
+            <a:extLst>
+              <a:ext uri="{FF2B5EF4-FFF2-40B4-BE49-F238E27FC236}">
+                <a16:creationId xmlns:a16="http://schemas.microsoft.com/office/drawing/2014/main" id="{0F03CCAE-E479-E18B-C26A-62DE055088ED}"/>
+              </a:ext>
+            </a:extLst>
+          </p:cNvPr>
+          <p:cNvSpPr>
+            <a:spLocks noGrp="1"/>
+          </p:cNvSpPr>
+          <p:nvPr>
+            <p:ph type="body" idx="1"/>
+          </p:nvPr>
+        </p:nvSpPr>
+        <p:spPr/>
+        <p:txBody>
+          <a:bodyPr/>
+          <a:lstStyle/>
+          <a:p>
+            <a:pPr marL="171450" indent="-171450">
+              <a:buFont typeface="Arial" panose="020B0604020202020204" pitchFamily="34" charset="0"/>
+              <a:buChar char="•"/>
+            </a:pPr>
+            <a:r>
+              <a:rPr lang="pt-BR" sz="1200" b="0" kern="1200" dirty="0">
+                <a:solidFill>
+                  <a:schemeClr val="tx1"/>
+                </a:solidFill>
+                <a:effectLst/>
+                <a:latin typeface="+mn-lt"/>
+                <a:ea typeface="+mn-ea"/>
+                <a:cs typeface="+mn-cs"/>
+              </a:rPr>
+              <a:t>Inicialização: i=10</a:t>
+            </a:r>
+          </a:p>
+          <a:p>
+            <a:pPr marL="171450" indent="-171450">
+              <a:buFont typeface="Arial" panose="020B0604020202020204" pitchFamily="34" charset="0"/>
+              <a:buChar char="•"/>
+            </a:pPr>
+            <a:r>
+              <a:rPr lang="pt-BR" sz="1200" b="0" kern="1200" dirty="0">
+                <a:solidFill>
+                  <a:schemeClr val="tx1"/>
+                </a:solidFill>
+                <a:effectLst/>
+                <a:latin typeface="+mn-lt"/>
+                <a:ea typeface="+mn-ea"/>
+                <a:cs typeface="+mn-cs"/>
+              </a:rPr>
+              <a:t>Condição de parada: i&gt;=10</a:t>
+            </a:r>
+          </a:p>
+          <a:p>
+            <a:pPr marL="171450" indent="-171450">
+              <a:buFont typeface="Arial" panose="020B0604020202020204" pitchFamily="34" charset="0"/>
+              <a:buChar char="•"/>
+            </a:pPr>
+            <a:r>
+              <a:rPr lang="pt-BR" sz="1200" b="0" kern="1200" dirty="0">
+                <a:solidFill>
+                  <a:schemeClr val="tx1"/>
+                </a:solidFill>
+                <a:effectLst/>
+                <a:latin typeface="+mn-lt"/>
+                <a:ea typeface="+mn-ea"/>
+                <a:cs typeface="+mn-cs"/>
+              </a:rPr>
+              <a:t>Passo de decremento: i--</a:t>
+            </a:r>
+          </a:p>
+        </p:txBody>
+      </p:sp>
+      <p:sp>
+        <p:nvSpPr>
+          <p:cNvPr id="4" name="Espaço Reservado para Número de Slide 3">
+            <a:extLst>
+              <a:ext uri="{FF2B5EF4-FFF2-40B4-BE49-F238E27FC236}">
+                <a16:creationId xmlns:a16="http://schemas.microsoft.com/office/drawing/2014/main" id="{8FBB05D6-9F41-4702-E3E9-53063DD91803}"/>
+              </a:ext>
+            </a:extLst>
+          </p:cNvPr>
+          <p:cNvSpPr>
+            <a:spLocks noGrp="1"/>
+          </p:cNvSpPr>
+          <p:nvPr>
+            <p:ph type="sldNum" sz="quarter" idx="5"/>
+          </p:nvPr>
+        </p:nvSpPr>
+        <p:spPr/>
+        <p:txBody>
+          <a:bodyPr/>
+          <a:lstStyle/>
+          <a:p>
+            <a:fld id="{80F36A49-A1DD-40F8-B8AD-E6F5365256CB}" type="slidenum">
+              <a:rPr lang="pt-BR" smtClean="0"/>
+              <a:t>52</a:t>
+            </a:fld>
+            <a:endParaRPr lang="pt-BR"/>
+          </a:p>
+        </p:txBody>
+      </p:sp>
+    </p:spTree>
+    <p:extLst>
+      <p:ext uri="{BB962C8B-B14F-4D97-AF65-F5344CB8AC3E}">
+        <p14:creationId xmlns:p14="http://schemas.microsoft.com/office/powerpoint/2010/main" val="1320522639"/>
       </p:ext>
     </p:extLst>
   </p:cSld>
@@ -9509,165 +9520,6 @@
         <p:cNvPr id="1" name="">
           <a:extLst>
             <a:ext uri="{FF2B5EF4-FFF2-40B4-BE49-F238E27FC236}">
-              <a16:creationId xmlns:a16="http://schemas.microsoft.com/office/drawing/2014/main" id="{EB1E513E-2B81-48E5-AD93-5FBA5C2E5B7D}"/>
-            </a:ext>
-          </a:extLst>
-        </p:cNvPr>
-        <p:cNvGrpSpPr/>
-        <p:nvPr/>
-      </p:nvGrpSpPr>
-      <p:grpSpPr>
-        <a:xfrm>
-          <a:off x="0" y="0"/>
-          <a:ext cx="0" cy="0"/>
-          <a:chOff x="0" y="0"/>
-          <a:chExt cx="0" cy="0"/>
-        </a:xfrm>
-      </p:grpSpPr>
-      <p:sp>
-        <p:nvSpPr>
-          <p:cNvPr id="2" name="Espaço Reservado para Imagem de Slide 1">
-            <a:extLst>
-              <a:ext uri="{FF2B5EF4-FFF2-40B4-BE49-F238E27FC236}">
-                <a16:creationId xmlns:a16="http://schemas.microsoft.com/office/drawing/2014/main" id="{6002FD15-ED4B-8A4B-77A0-07E09B201A3A}"/>
-              </a:ext>
-            </a:extLst>
-          </p:cNvPr>
-          <p:cNvSpPr>
-            <a:spLocks noGrp="1" noRot="1" noChangeAspect="1"/>
-          </p:cNvSpPr>
-          <p:nvPr>
-            <p:ph type="sldImg"/>
-          </p:nvPr>
-        </p:nvSpPr>
-        <p:spPr/>
-      </p:sp>
-      <p:sp>
-        <p:nvSpPr>
-          <p:cNvPr id="3" name="Espaço Reservado para Anotações 2">
-            <a:extLst>
-              <a:ext uri="{FF2B5EF4-FFF2-40B4-BE49-F238E27FC236}">
-                <a16:creationId xmlns:a16="http://schemas.microsoft.com/office/drawing/2014/main" id="{0F03CCAE-E479-E18B-C26A-62DE055088ED}"/>
-              </a:ext>
-            </a:extLst>
-          </p:cNvPr>
-          <p:cNvSpPr>
-            <a:spLocks noGrp="1"/>
-          </p:cNvSpPr>
-          <p:nvPr>
-            <p:ph type="body" idx="1"/>
-          </p:nvPr>
-        </p:nvSpPr>
-        <p:spPr/>
-        <p:txBody>
-          <a:bodyPr/>
-          <a:lstStyle/>
-          <a:p>
-            <a:pPr marL="171450" indent="-171450">
-              <a:buFont typeface="Arial" panose="020B0604020202020204" pitchFamily="34" charset="0"/>
-              <a:buChar char="•"/>
-            </a:pPr>
-            <a:r>
-              <a:rPr lang="pt-BR" sz="1200" b="0" kern="1200" dirty="0">
-                <a:solidFill>
-                  <a:schemeClr val="tx1"/>
-                </a:solidFill>
-                <a:effectLst/>
-                <a:latin typeface="+mn-lt"/>
-                <a:ea typeface="+mn-ea"/>
-                <a:cs typeface="+mn-cs"/>
-              </a:rPr>
-              <a:t>Inicialização: i=10</a:t>
-            </a:r>
-          </a:p>
-          <a:p>
-            <a:pPr marL="171450" indent="-171450">
-              <a:buFont typeface="Arial" panose="020B0604020202020204" pitchFamily="34" charset="0"/>
-              <a:buChar char="•"/>
-            </a:pPr>
-            <a:r>
-              <a:rPr lang="pt-BR" sz="1200" b="0" kern="1200" dirty="0">
-                <a:solidFill>
-                  <a:schemeClr val="tx1"/>
-                </a:solidFill>
-                <a:effectLst/>
-                <a:latin typeface="+mn-lt"/>
-                <a:ea typeface="+mn-ea"/>
-                <a:cs typeface="+mn-cs"/>
-              </a:rPr>
-              <a:t>Condição de parada: i&gt;=10</a:t>
-            </a:r>
-          </a:p>
-          <a:p>
-            <a:pPr marL="171450" indent="-171450">
-              <a:buFont typeface="Arial" panose="020B0604020202020204" pitchFamily="34" charset="0"/>
-              <a:buChar char="•"/>
-            </a:pPr>
-            <a:r>
-              <a:rPr lang="pt-BR" sz="1200" b="0" kern="1200" dirty="0">
-                <a:solidFill>
-                  <a:schemeClr val="tx1"/>
-                </a:solidFill>
-                <a:effectLst/>
-                <a:latin typeface="+mn-lt"/>
-                <a:ea typeface="+mn-ea"/>
-                <a:cs typeface="+mn-cs"/>
-              </a:rPr>
-              <a:t>Passo de decremento: i--</a:t>
-            </a:r>
-          </a:p>
-        </p:txBody>
-      </p:sp>
-      <p:sp>
-        <p:nvSpPr>
-          <p:cNvPr id="4" name="Espaço Reservado para Número de Slide 3">
-            <a:extLst>
-              <a:ext uri="{FF2B5EF4-FFF2-40B4-BE49-F238E27FC236}">
-                <a16:creationId xmlns:a16="http://schemas.microsoft.com/office/drawing/2014/main" id="{8FBB05D6-9F41-4702-E3E9-53063DD91803}"/>
-              </a:ext>
-            </a:extLst>
-          </p:cNvPr>
-          <p:cNvSpPr>
-            <a:spLocks noGrp="1"/>
-          </p:cNvSpPr>
-          <p:nvPr>
-            <p:ph type="sldNum" sz="quarter" idx="5"/>
-          </p:nvPr>
-        </p:nvSpPr>
-        <p:spPr/>
-        <p:txBody>
-          <a:bodyPr/>
-          <a:lstStyle/>
-          <a:p>
-            <a:fld id="{80F36A49-A1DD-40F8-B8AD-E6F5365256CB}" type="slidenum">
-              <a:rPr lang="pt-BR" smtClean="0"/>
-              <a:t>53</a:t>
-            </a:fld>
-            <a:endParaRPr lang="pt-BR"/>
-          </a:p>
-        </p:txBody>
-      </p:sp>
-    </p:spTree>
-    <p:extLst>
-      <p:ext uri="{BB962C8B-B14F-4D97-AF65-F5344CB8AC3E}">
-        <p14:creationId xmlns:p14="http://schemas.microsoft.com/office/powerpoint/2010/main" val="1320522639"/>
-      </p:ext>
-    </p:extLst>
-  </p:cSld>
-  <p:clrMapOvr>
-    <a:masterClrMapping/>
-  </p:clrMapOvr>
-</p:notes>
-</file>
-
-<file path=ppt/notesSlides/notesSlide51.xml><?xml version="1.0" encoding="utf-8"?>
-<p:notes xmlns:a="http://schemas.openxmlformats.org/drawingml/2006/main" xmlns:r="http://schemas.openxmlformats.org/officeDocument/2006/relationships" xmlns:p="http://schemas.openxmlformats.org/presentationml/2006/main">
-  <p:cSld>
-    <p:spTree>
-      <p:nvGrpSpPr>
-        <p:cNvPr id="1" name="">
-          <a:extLst>
-            <a:ext uri="{FF2B5EF4-FFF2-40B4-BE49-F238E27FC236}">
               <a16:creationId xmlns:a16="http://schemas.microsoft.com/office/drawing/2014/main" id="{2EF5E35E-2986-D614-CECC-AF822E0763F8}"/>
             </a:ext>
           </a:extLst>
@@ -9788,7 +9640,7 @@
           <a:p>
             <a:fld id="{80F36A49-A1DD-40F8-B8AD-E6F5365256CB}" type="slidenum">
               <a:rPr lang="pt-BR" smtClean="0"/>
-              <a:t>54</a:t>
+              <a:t>53</a:t>
             </a:fld>
             <a:endParaRPr lang="pt-BR"/>
           </a:p>
@@ -30123,280 +29975,132 @@
           </a:p>
         </p:txBody>
       </p:sp>
-      <mc:AlternateContent xmlns:mc="http://schemas.openxmlformats.org/markup-compatibility/2006">
-        <mc:Choice xmlns:a14="http://schemas.microsoft.com/office/drawing/2010/main" Requires="a14">
-          <p:sp>
-            <p:nvSpPr>
-              <p:cNvPr id="6" name="Espaço Reservado para Conteúdo 5">
-                <a:extLst>
-                  <a:ext uri="{FF2B5EF4-FFF2-40B4-BE49-F238E27FC236}">
-                    <a16:creationId xmlns:a16="http://schemas.microsoft.com/office/drawing/2014/main" id="{D77D6796-5BC6-76EA-C684-B51E7AF258F0}"/>
-                  </a:ext>
-                </a:extLst>
-              </p:cNvPr>
-              <p:cNvSpPr>
-                <a:spLocks noGrp="1"/>
-              </p:cNvSpPr>
-              <p:nvPr>
-                <p:ph idx="1"/>
-              </p:nvPr>
-            </p:nvSpPr>
-            <p:spPr>
-              <a:xfrm>
-                <a:off x="1692363" y="1552668"/>
-                <a:ext cx="9664259" cy="4963787"/>
-              </a:xfrm>
-            </p:spPr>
-            <p:txBody>
-              <a:bodyPr>
-                <a:normAutofit/>
-              </a:bodyPr>
-              <a:lstStyle/>
-              <a:p>
-                <a:r>
-                  <a:rPr lang="pt-BR" sz="2400" dirty="0"/>
-                  <a:t>Análogo ao SE-ENTÃO do Visual G.</a:t>
-                </a:r>
-              </a:p>
-              <a:p>
-                <a:r>
-                  <a:rPr lang="pt-BR" sz="2400" dirty="0"/>
-                  <a:t>A execução de um determinado bloco de comando é executada somente se uma condição for satisfeita.</a:t>
-                </a:r>
-              </a:p>
-              <a:p>
-                <a:r>
-                  <a:rPr lang="pt-BR" sz="2400" dirty="0"/>
-                  <a:t>Caso a condição não seja satisfeita, o programa apenas segue a execução, ignorando o IF.</a:t>
-                </a:r>
-              </a:p>
-              <a:p>
-                <a:endParaRPr lang="pt-BR" sz="2400" dirty="0"/>
-              </a:p>
-              <a:p>
-                <a:r>
-                  <a:rPr lang="pt-BR" sz="2400" dirty="0"/>
-                  <a:t> Sintaxe do IF:</a:t>
-                </a:r>
-              </a:p>
-              <a:p>
-                <a:endParaRPr lang="pt-BR" sz="2400" dirty="0"/>
-              </a:p>
-              <a:p>
-                <a:pPr marL="457200" lvl="1" indent="0">
-                  <a:buNone/>
-                </a:pPr>
-                <a14:m>
-                  <m:oMathPara xmlns:m="http://schemas.openxmlformats.org/officeDocument/2006/math">
-                    <m:oMathParaPr>
-                      <m:jc m:val="left"/>
-                    </m:oMathParaPr>
-                    <m:oMath xmlns:m="http://schemas.openxmlformats.org/officeDocument/2006/math">
-                      <m:r>
-                        <a:rPr lang="pt-BR" sz="2200" i="1" dirty="0" smtClean="0">
-                          <a:latin typeface="Cambria Math" panose="02040503050406030204" pitchFamily="18" charset="0"/>
-                        </a:rPr>
-                        <m:t>𝐼𝑓</m:t>
-                      </m:r>
-                      <m:r>
-                        <a:rPr lang="pt-BR" sz="2200" i="1" dirty="0" smtClean="0">
-                          <a:latin typeface="Cambria Math" panose="02040503050406030204" pitchFamily="18" charset="0"/>
-                        </a:rPr>
-                        <m:t>(</m:t>
-                      </m:r>
-                      <m:r>
-                        <a:rPr lang="pt-BR" sz="2200" i="1" dirty="0" smtClean="0">
-                          <a:latin typeface="Cambria Math" panose="02040503050406030204" pitchFamily="18" charset="0"/>
-                        </a:rPr>
-                        <m:t>𝑐𝑜𝑛𝑑𝑖</m:t>
-                      </m:r>
-                      <m:r>
-                        <a:rPr lang="pt-BR" sz="2200" i="1" dirty="0" smtClean="0">
-                          <a:latin typeface="Cambria Math" panose="02040503050406030204" pitchFamily="18" charset="0"/>
-                        </a:rPr>
-                        <m:t>çã</m:t>
-                      </m:r>
-                      <m:r>
-                        <a:rPr lang="pt-BR" sz="2200" i="1" dirty="0" smtClean="0">
-                          <a:latin typeface="Cambria Math" panose="02040503050406030204" pitchFamily="18" charset="0"/>
-                        </a:rPr>
-                        <m:t>𝑜</m:t>
-                      </m:r>
-                      <m:r>
-                        <a:rPr lang="pt-BR" sz="2200" i="1" dirty="0" smtClean="0">
-                          <a:latin typeface="Cambria Math" panose="02040503050406030204" pitchFamily="18" charset="0"/>
-                        </a:rPr>
-                        <m:t>)</m:t>
-                      </m:r>
-                    </m:oMath>
-                  </m:oMathPara>
-                  <m:oMathPara xmlns:m="http://schemas.openxmlformats.org/officeDocument/2006/math">
-                    <m:oMathParaPr>
-                      <m:jc m:val="left"/>
-                    </m:oMathParaPr>
-                    <m:oMath xmlns:m="http://schemas.openxmlformats.org/officeDocument/2006/math">
-                      <m:r>
-                        <a:rPr lang="pt-BR" sz="2200" i="1" dirty="0" smtClean="0">
-                          <a:latin typeface="Cambria Math" panose="02040503050406030204" pitchFamily="18" charset="0"/>
-                        </a:rPr>
-                        <m:t>{</m:t>
-                      </m:r>
-                    </m:oMath>
-                  </m:oMathPara>
-                  <m:oMathPara xmlns:m="http://schemas.openxmlformats.org/officeDocument/2006/math">
-                    <m:oMathParaPr>
-                      <m:jc m:val="left"/>
-                    </m:oMathParaPr>
-                    <m:oMath xmlns:m="http://schemas.openxmlformats.org/officeDocument/2006/math">
-                      <m:r>
-                        <a:rPr lang="pt-BR" sz="2200" i="1" dirty="0" smtClean="0">
-                          <a:latin typeface="Cambria Math" panose="02040503050406030204" pitchFamily="18" charset="0"/>
-                        </a:rPr>
-                        <m:t>	</m:t>
-                      </m:r>
-                      <m:r>
-                        <a:rPr lang="pt-BR" sz="2200" b="0" i="1" dirty="0" smtClean="0">
-                          <a:latin typeface="Cambria Math" panose="02040503050406030204" pitchFamily="18" charset="0"/>
-                        </a:rPr>
-                        <m:t>      </m:t>
-                      </m:r>
-                      <m:r>
-                        <a:rPr lang="pt-BR" sz="2200" i="1" dirty="0" smtClean="0">
-                          <a:latin typeface="Cambria Math" panose="02040503050406030204" pitchFamily="18" charset="0"/>
-                        </a:rPr>
-                        <m:t>𝑏𝑙𝑜𝑐𝑜</m:t>
-                      </m:r>
-                      <m:r>
-                        <a:rPr lang="pt-BR" sz="2200" i="1" dirty="0" smtClean="0">
-                          <a:latin typeface="Cambria Math" panose="02040503050406030204" pitchFamily="18" charset="0"/>
-                        </a:rPr>
-                        <m:t> </m:t>
-                      </m:r>
-                      <m:r>
-                        <a:rPr lang="pt-BR" sz="2200" i="1" dirty="0" smtClean="0">
-                          <a:latin typeface="Cambria Math" panose="02040503050406030204" pitchFamily="18" charset="0"/>
-                        </a:rPr>
-                        <m:t>𝑑𝑒</m:t>
-                      </m:r>
-                      <m:r>
-                        <a:rPr lang="pt-BR" sz="2200" i="1" dirty="0" smtClean="0">
-                          <a:latin typeface="Cambria Math" panose="02040503050406030204" pitchFamily="18" charset="0"/>
-                        </a:rPr>
-                        <m:t> </m:t>
-                      </m:r>
-                      <m:r>
-                        <a:rPr lang="pt-BR" sz="2200" i="1" dirty="0" smtClean="0">
-                          <a:latin typeface="Cambria Math" panose="02040503050406030204" pitchFamily="18" charset="0"/>
-                        </a:rPr>
-                        <m:t>𝑐𝑜𝑚𝑎𝑛𝑑𝑜</m:t>
-                      </m:r>
-                    </m:oMath>
-                  </m:oMathPara>
-                  <m:oMathPara xmlns:m="http://schemas.openxmlformats.org/officeDocument/2006/math">
-                    <m:oMathParaPr>
-                      <m:jc m:val="left"/>
-                    </m:oMathParaPr>
-                    <m:oMath xmlns:m="http://schemas.openxmlformats.org/officeDocument/2006/math">
-                      <m:r>
-                        <a:rPr lang="pt-BR" sz="2200" i="1" dirty="0" smtClean="0">
-                          <a:latin typeface="Cambria Math" panose="02040503050406030204" pitchFamily="18" charset="0"/>
-                        </a:rPr>
-                        <m:t>}</m:t>
-                      </m:r>
-                    </m:oMath>
-                  </m:oMathPara>
-                </a14:m>
-              </a:p>
-              <a:p>
-                <a:pPr marL="457200" lvl="1" indent="0">
-                  <a:buNone/>
-                </a:pPr>
-              </a:p>
-              <a:p>
-                <a:pPr marL="457200" lvl="1" indent="0">
-                  <a:buNone/>
-                </a:pPr>
-              </a:p>
-              <a:p>
-                <a:pPr marL="457200" lvl="1" indent="0">
-                  <a:buNone/>
-                </a:pPr>
-              </a:p>
-              <a:p>
-                <a:pPr marL="0" indent="0">
-                  <a:buNone/>
-                </a:pPr>
-                <a:endParaRPr lang="pt-BR" sz="2400" dirty="0"/>
-              </a:p>
-              <a:p>
-                <a:pPr lvl="1"/>
-                <a:endParaRPr lang="pt-BR" sz="2000" b="1" i="1" dirty="0"/>
-              </a:p>
-              <a:p>
-                <a:pPr lvl="1"/>
-                <a:endParaRPr lang="pt-BR" sz="2000" b="1" i="1" dirty="0"/>
-              </a:p>
-              <a:p>
-                <a:pPr lvl="1"/>
-                <a:endParaRPr lang="pt-BR" sz="1800" b="1" i="1" dirty="0"/>
-              </a:p>
-              <a:p>
-                <a:pPr lvl="1"/>
-                <a:endParaRPr lang="pt-BR" sz="1800" b="1" i="1" dirty="0"/>
-              </a:p>
-            </p:txBody>
-          </p:sp>
-        </mc:Choice>
-        <mc:Fallback>
-          <p:sp>
-            <p:nvSpPr>
-              <p:cNvPr id="6" name="Espaço Reservado para Conteúdo 5">
-                <a:extLst>
-                  <a:ext uri="{FF2B5EF4-FFF2-40B4-BE49-F238E27FC236}">
-                    <a16:creationId xmlns:a16="http://schemas.microsoft.com/office/drawing/2014/main" id="{D77D6796-5BC6-76EA-C684-B51E7AF258F0}"/>
-                  </a:ext>
-                </a:extLst>
-              </p:cNvPr>
-              <p:cNvSpPr>
-                <a:spLocks noGrp="1" noRot="1" noChangeAspect="1" noMove="1" noResize="1" noEditPoints="1" noAdjustHandles="1" noChangeArrowheads="1" noChangeShapeType="1" noTextEdit="1"/>
-              </p:cNvSpPr>
-              <p:nvPr>
-                <p:ph idx="1"/>
-              </p:nvPr>
-            </p:nvSpPr>
-            <p:spPr>
-              <a:xfrm>
-                <a:off x="1692363" y="1552668"/>
-                <a:ext cx="9664259" cy="4963787"/>
-              </a:xfrm>
-              <a:blipFill>
-                <a:blip r:embed="rId3"/>
-                <a:stretch>
-                  <a:fillRect l="-883" t="-1720"/>
-                </a:stretch>
-              </a:blipFill>
-            </p:spPr>
-            <p:txBody>
-              <a:bodyPr/>
-              <a:lstStyle/>
-              <a:p>
-                <a:r>
-                  <a:rPr lang="pt-BR">
-                    <a:noFill/>
-                  </a:rPr>
-                  <a:t> </a:t>
-                </a:r>
-              </a:p>
-            </p:txBody>
-          </p:sp>
-        </mc:Fallback>
-      </mc:AlternateContent>
+      <p:sp>
+        <p:nvSpPr>
+          <p:cNvPr id="6" name="Espaço Reservado para Conteúdo 5">
+            <a:extLst>
+              <a:ext uri="{FF2B5EF4-FFF2-40B4-BE49-F238E27FC236}">
+                <a16:creationId xmlns:a16="http://schemas.microsoft.com/office/drawing/2014/main" id="{D77D6796-5BC6-76EA-C684-B51E7AF258F0}"/>
+              </a:ext>
+            </a:extLst>
+          </p:cNvPr>
+          <p:cNvSpPr>
+            <a:spLocks noGrp="1"/>
+          </p:cNvSpPr>
+          <p:nvPr>
+            <p:ph idx="1"/>
+          </p:nvPr>
+        </p:nvSpPr>
+        <p:spPr>
+          <a:xfrm>
+            <a:off x="1692363" y="1552668"/>
+            <a:ext cx="9664259" cy="4963787"/>
+          </a:xfrm>
+        </p:spPr>
+        <p:txBody>
+          <a:bodyPr>
+            <a:normAutofit/>
+          </a:bodyPr>
+          <a:lstStyle/>
+          <a:p>
+            <a:r>
+              <a:rPr lang="pt-BR" sz="2400" dirty="0"/>
+              <a:t>Análogo ao SE-ENTÃO do Visual G.</a:t>
+            </a:r>
+          </a:p>
+          <a:p>
+            <a:r>
+              <a:rPr lang="pt-BR" sz="2400" dirty="0"/>
+              <a:t>A execução de um determinado bloco de comando é executada somente se uma condição for satisfeita.</a:t>
+            </a:r>
+          </a:p>
+          <a:p>
+            <a:r>
+              <a:rPr lang="pt-BR" sz="2400" dirty="0"/>
+              <a:t>Caso a condição não seja satisfeita, o programa apenas segue a execução.</a:t>
+            </a:r>
+          </a:p>
+          <a:p>
+            <a:endParaRPr lang="pt-BR" sz="2400" dirty="0"/>
+          </a:p>
+          <a:p>
+            <a:pPr marL="457200" lvl="1" indent="0">
+              <a:buNone/>
+            </a:pPr>
+            <a:endParaRPr lang="pt-BR" sz="2400" dirty="0"/>
+          </a:p>
+          <a:p>
+            <a:pPr marL="457200" lvl="1" indent="0">
+              <a:buNone/>
+            </a:pPr>
+            <a:endParaRPr lang="pt-BR" sz="2400" dirty="0"/>
+          </a:p>
+          <a:p>
+            <a:pPr marL="457200" lvl="1" indent="0">
+              <a:buNone/>
+            </a:pPr>
+            <a:endParaRPr lang="pt-BR" sz="2400" dirty="0"/>
+          </a:p>
+          <a:p>
+            <a:pPr marL="0" indent="0">
+              <a:buNone/>
+            </a:pPr>
+            <a:endParaRPr lang="pt-BR" sz="2400" dirty="0"/>
+          </a:p>
+          <a:p>
+            <a:pPr lvl="1"/>
+            <a:endParaRPr lang="pt-BR" sz="2000" b="1" i="1" dirty="0"/>
+          </a:p>
+          <a:p>
+            <a:pPr lvl="1"/>
+            <a:endParaRPr lang="pt-BR" sz="2000" b="1" i="1" dirty="0"/>
+          </a:p>
+          <a:p>
+            <a:pPr lvl="1"/>
+            <a:endParaRPr lang="pt-BR" sz="1800" b="1" i="1" dirty="0"/>
+          </a:p>
+          <a:p>
+            <a:pPr lvl="1"/>
+            <a:endParaRPr lang="pt-BR" sz="1800" b="1" i="1" dirty="0"/>
+          </a:p>
+        </p:txBody>
+      </p:sp>
       <p:pic>
         <p:nvPicPr>
           <p:cNvPr id="8" name="Imagem 7">
             <a:extLst>
               <a:ext uri="{FF2B5EF4-FFF2-40B4-BE49-F238E27FC236}">
                 <a16:creationId xmlns:a16="http://schemas.microsoft.com/office/drawing/2014/main" id="{539EE381-F776-2E97-C4A7-32D478A0A67D}"/>
+              </a:ext>
+            </a:extLst>
+          </p:cNvPr>
+          <p:cNvPicPr>
+            <a:picLocks noChangeAspect="1"/>
+          </p:cNvPicPr>
+          <p:nvPr/>
+        </p:nvPicPr>
+        <p:blipFill>
+          <a:blip r:embed="rId3"/>
+          <a:stretch>
+            <a:fillRect/>
+          </a:stretch>
+        </p:blipFill>
+        <p:spPr>
+          <a:xfrm>
+            <a:off x="5819754" y="3580955"/>
+            <a:ext cx="4541460" cy="3162606"/>
+          </a:xfrm>
+          <a:prstGeom prst="rect">
+            <a:avLst/>
+          </a:prstGeom>
+        </p:spPr>
+      </p:pic>
+      <p:pic>
+        <p:nvPicPr>
+          <p:cNvPr id="7" name="Imagem 6">
+            <a:extLst>
+              <a:ext uri="{FF2B5EF4-FFF2-40B4-BE49-F238E27FC236}">
+                <a16:creationId xmlns:a16="http://schemas.microsoft.com/office/drawing/2014/main" id="{E3AFEDF7-068B-2AC1-E2DA-8F030D42F925}"/>
               </a:ext>
             </a:extLst>
           </p:cNvPr>
@@ -30413,14 +30117,78 @@
         </p:blipFill>
         <p:spPr>
           <a:xfrm>
-            <a:off x="6096000" y="3695394"/>
-            <a:ext cx="4541460" cy="3162606"/>
+            <a:off x="1830786" y="3279597"/>
+            <a:ext cx="3414314" cy="3578403"/>
           </a:xfrm>
           <a:prstGeom prst="rect">
             <a:avLst/>
           </a:prstGeom>
         </p:spPr>
       </p:pic>
+      <p:sp>
+        <p:nvSpPr>
+          <p:cNvPr id="9" name="Retângulo 8">
+            <a:extLst>
+              <a:ext uri="{FF2B5EF4-FFF2-40B4-BE49-F238E27FC236}">
+                <a16:creationId xmlns:a16="http://schemas.microsoft.com/office/drawing/2014/main" id="{B328CE5F-6CEE-1B61-6D4E-990534E16CE0}"/>
+              </a:ext>
+            </a:extLst>
+          </p:cNvPr>
+          <p:cNvSpPr/>
+          <p:nvPr/>
+        </p:nvSpPr>
+        <p:spPr>
+          <a:xfrm>
+            <a:off x="2490788" y="5743575"/>
+            <a:ext cx="1219200" cy="319088"/>
+          </a:xfrm>
+          <a:prstGeom prst="rect">
+            <a:avLst/>
+          </a:prstGeom>
+          <a:solidFill>
+            <a:srgbClr val="E1FFE7"/>
+          </a:solidFill>
+          <a:ln>
+            <a:noFill/>
+          </a:ln>
+        </p:spPr>
+        <p:style>
+          <a:lnRef idx="2">
+            <a:schemeClr val="accent1">
+              <a:shade val="15000"/>
+            </a:schemeClr>
+          </a:lnRef>
+          <a:fillRef idx="1">
+            <a:schemeClr val="accent1"/>
+          </a:fillRef>
+          <a:effectRef idx="0">
+            <a:schemeClr val="accent1"/>
+          </a:effectRef>
+          <a:fontRef idx="minor">
+            <a:schemeClr val="lt1"/>
+          </a:fontRef>
+        </p:style>
+        <p:txBody>
+          <a:bodyPr rtlCol="0" anchor="ctr"/>
+          <a:lstStyle/>
+          <a:p>
+            <a:pPr algn="ctr"/>
+            <a:r>
+              <a:rPr lang="pt-BR" sz="1400" dirty="0" err="1">
+                <a:solidFill>
+                  <a:srgbClr val="2F8D46"/>
+                </a:solidFill>
+              </a:rPr>
+              <a:t>Code</a:t>
+            </a:r>
+            <a:endParaRPr lang="pt-BR" sz="1400" dirty="0">
+              <a:solidFill>
+                <a:srgbClr val="2F8D46"/>
+              </a:solidFill>
+            </a:endParaRPr>
+          </a:p>
+        </p:txBody>
+      </p:sp>
     </p:spTree>
     <p:extLst>
       <p:ext uri="{BB962C8B-B14F-4D97-AF65-F5344CB8AC3E}">
@@ -30594,379 +30362,114 @@
           </a:p>
         </p:txBody>
       </p:sp>
-      <mc:AlternateContent xmlns:mc="http://schemas.openxmlformats.org/markup-compatibility/2006">
-        <mc:Choice xmlns:a14="http://schemas.microsoft.com/office/drawing/2010/main" Requires="a14">
-          <p:sp>
-            <p:nvSpPr>
-              <p:cNvPr id="6" name="Espaço Reservado para Conteúdo 5">
-                <a:extLst>
-                  <a:ext uri="{FF2B5EF4-FFF2-40B4-BE49-F238E27FC236}">
-                    <a16:creationId xmlns:a16="http://schemas.microsoft.com/office/drawing/2014/main" id="{402F2442-8B72-6182-8933-F74EC87244EE}"/>
-                  </a:ext>
-                </a:extLst>
-              </p:cNvPr>
-              <p:cNvSpPr>
-                <a:spLocks noGrp="1"/>
-              </p:cNvSpPr>
-              <p:nvPr>
-                <p:ph idx="1"/>
-              </p:nvPr>
-            </p:nvSpPr>
-            <p:spPr>
-              <a:xfrm>
-                <a:off x="1692363" y="1552668"/>
-                <a:ext cx="10014215" cy="5305332"/>
-              </a:xfrm>
-            </p:spPr>
-            <p:txBody>
-              <a:bodyPr>
-                <a:normAutofit/>
-              </a:bodyPr>
-              <a:lstStyle/>
-              <a:p>
-                <a:r>
-                  <a:rPr lang="pt-BR" sz="2400" dirty="0"/>
-                  <a:t>Análogo ao SE-ENTÃO-SENÃO do Visual G.</a:t>
-                </a:r>
-              </a:p>
-              <a:p>
-                <a:r>
-                  <a:rPr lang="pt-BR" sz="2400" dirty="0"/>
-                  <a:t>A execução de um determinado trecho é executada somente se a condição for satisfeita.</a:t>
-                </a:r>
-              </a:p>
-              <a:p>
-                <a:r>
-                  <a:rPr lang="pt-BR" sz="2400" dirty="0"/>
-                  <a:t>Caso a condição não seja satisfeita, um outro bloco de comando é executado.</a:t>
-                </a:r>
-              </a:p>
-              <a:p>
-                <a:endParaRPr lang="pt-BR" sz="2400" dirty="0"/>
-              </a:p>
-              <a:p>
-                <a:r>
-                  <a:rPr lang="pt-BR" sz="2400" dirty="0"/>
-                  <a:t>Sintaxe do IF-ELSE:</a:t>
-                </a:r>
-              </a:p>
-              <a:p>
-                <a:endParaRPr lang="pt-BR" sz="2400" dirty="0"/>
-              </a:p>
-              <a:p>
-                <a:pPr marL="457200" lvl="1" indent="0">
-                  <a:buNone/>
-                </a:pPr>
-                <a14:m>
-                  <m:oMathPara xmlns:m="http://schemas.openxmlformats.org/officeDocument/2006/math">
-                    <m:oMathParaPr>
-                      <m:jc m:val="left"/>
-                    </m:oMathParaPr>
-                    <m:oMath xmlns:m="http://schemas.openxmlformats.org/officeDocument/2006/math">
-                      <m:r>
-                        <a:rPr lang="pt-BR" sz="2200" i="1" dirty="0" smtClean="0">
-                          <a:latin typeface="Cambria Math" panose="02040503050406030204" pitchFamily="18" charset="0"/>
-                        </a:rPr>
-                        <m:t>𝐼𝑓</m:t>
-                      </m:r>
-                      <m:r>
-                        <a:rPr lang="pt-BR" sz="2200" i="1" dirty="0" smtClean="0">
-                          <a:latin typeface="Cambria Math" panose="02040503050406030204" pitchFamily="18" charset="0"/>
-                        </a:rPr>
-                        <m:t>(</m:t>
-                      </m:r>
-                      <m:r>
-                        <a:rPr lang="pt-BR" sz="2200" i="1" dirty="0" smtClean="0">
-                          <a:latin typeface="Cambria Math" panose="02040503050406030204" pitchFamily="18" charset="0"/>
-                        </a:rPr>
-                        <m:t>𝑐𝑜𝑛𝑑𝑖</m:t>
-                      </m:r>
-                      <m:r>
-                        <a:rPr lang="pt-BR" sz="2200" i="1" dirty="0" smtClean="0">
-                          <a:latin typeface="Cambria Math" panose="02040503050406030204" pitchFamily="18" charset="0"/>
-                        </a:rPr>
-                        <m:t>çã</m:t>
-                      </m:r>
-                      <m:r>
-                        <a:rPr lang="pt-BR" sz="2200" i="1" dirty="0" smtClean="0">
-                          <a:latin typeface="Cambria Math" panose="02040503050406030204" pitchFamily="18" charset="0"/>
-                        </a:rPr>
-                        <m:t>𝑜</m:t>
-                      </m:r>
-                      <m:r>
-                        <a:rPr lang="pt-BR" sz="2200" i="1" dirty="0" smtClean="0">
-                          <a:latin typeface="Cambria Math" panose="02040503050406030204" pitchFamily="18" charset="0"/>
-                        </a:rPr>
-                        <m:t>)</m:t>
-                      </m:r>
-                    </m:oMath>
-                  </m:oMathPara>
-                  <m:oMathPara xmlns:m="http://schemas.openxmlformats.org/officeDocument/2006/math">
-                    <m:oMathParaPr>
-                      <m:jc m:val="left"/>
-                    </m:oMathParaPr>
-                    <m:oMath xmlns:m="http://schemas.openxmlformats.org/officeDocument/2006/math">
-                      <m:r>
-                        <a:rPr lang="pt-BR" sz="2200" i="1" dirty="0" smtClean="0">
-                          <a:latin typeface="Cambria Math" panose="02040503050406030204" pitchFamily="18" charset="0"/>
-                        </a:rPr>
-                        <m:t>{</m:t>
-                      </m:r>
-                    </m:oMath>
-                  </m:oMathPara>
-                  <m:oMathPara xmlns:m="http://schemas.openxmlformats.org/officeDocument/2006/math">
-                    <m:oMathParaPr>
-                      <m:jc m:val="left"/>
-                    </m:oMathParaPr>
-                    <m:oMath xmlns:m="http://schemas.openxmlformats.org/officeDocument/2006/math">
-                      <m:r>
-                        <a:rPr lang="pt-BR" sz="2200" i="1" dirty="0" smtClean="0">
-                          <a:latin typeface="Cambria Math" panose="02040503050406030204" pitchFamily="18" charset="0"/>
-                        </a:rPr>
-                        <m:t>	</m:t>
-                      </m:r>
-                      <m:r>
-                        <a:rPr lang="pt-BR" sz="2200" b="0" i="1" dirty="0" smtClean="0">
-                          <a:latin typeface="Cambria Math" panose="02040503050406030204" pitchFamily="18" charset="0"/>
-                        </a:rPr>
-                        <m:t>      </m:t>
-                      </m:r>
-                      <m:r>
-                        <a:rPr lang="pt-BR" sz="2200" i="1" dirty="0" smtClean="0">
-                          <a:latin typeface="Cambria Math" panose="02040503050406030204" pitchFamily="18" charset="0"/>
-                        </a:rPr>
-                        <m:t>𝑏𝑙𝑜𝑐𝑜</m:t>
-                      </m:r>
-                      <m:r>
-                        <a:rPr lang="pt-BR" sz="2200" i="1" dirty="0" smtClean="0">
-                          <a:latin typeface="Cambria Math" panose="02040503050406030204" pitchFamily="18" charset="0"/>
-                        </a:rPr>
-                        <m:t> </m:t>
-                      </m:r>
-                      <m:r>
-                        <a:rPr lang="pt-BR" sz="2200" i="1" dirty="0" smtClean="0">
-                          <a:latin typeface="Cambria Math" panose="02040503050406030204" pitchFamily="18" charset="0"/>
-                        </a:rPr>
-                        <m:t>𝑑𝑒</m:t>
-                      </m:r>
-                      <m:r>
-                        <a:rPr lang="pt-BR" sz="2200" i="1" dirty="0" smtClean="0">
-                          <a:latin typeface="Cambria Math" panose="02040503050406030204" pitchFamily="18" charset="0"/>
-                        </a:rPr>
-                        <m:t> </m:t>
-                      </m:r>
-                      <m:r>
-                        <a:rPr lang="pt-BR" sz="2200" i="1" dirty="0" smtClean="0">
-                          <a:latin typeface="Cambria Math" panose="02040503050406030204" pitchFamily="18" charset="0"/>
-                        </a:rPr>
-                        <m:t>𝑐𝑜𝑚𝑎𝑛𝑑𝑜</m:t>
-                      </m:r>
-                      <m:r>
-                        <a:rPr lang="pt-BR" sz="2200" b="0" i="1" dirty="0" smtClean="0">
-                          <a:latin typeface="Cambria Math" panose="02040503050406030204" pitchFamily="18" charset="0"/>
-                        </a:rPr>
-                        <m:t>1</m:t>
-                      </m:r>
-                    </m:oMath>
-                  </m:oMathPara>
-                  <m:oMathPara xmlns:m="http://schemas.openxmlformats.org/officeDocument/2006/math">
-                    <m:oMathParaPr>
-                      <m:jc m:val="left"/>
-                    </m:oMathParaPr>
-                    <m:oMath xmlns:m="http://schemas.openxmlformats.org/officeDocument/2006/math">
-                      <m:r>
-                        <a:rPr lang="pt-BR" sz="2200" i="1" dirty="0" smtClean="0">
-                          <a:latin typeface="Cambria Math" panose="02040503050406030204" pitchFamily="18" charset="0"/>
-                        </a:rPr>
-                        <m:t>}</m:t>
-                      </m:r>
-                      <m:r>
-                        <a:rPr lang="pt-BR" sz="2200" b="0" i="1" dirty="0" smtClean="0">
-                          <a:latin typeface="Cambria Math" panose="02040503050406030204" pitchFamily="18" charset="0"/>
-                        </a:rPr>
-                        <m:t> </m:t>
-                      </m:r>
-                      <m:r>
-                        <a:rPr lang="pt-BR" sz="2200" b="0" i="1" dirty="0" smtClean="0">
-                          <a:latin typeface="Cambria Math" panose="02040503050406030204" pitchFamily="18" charset="0"/>
-                        </a:rPr>
-                        <m:t>𝑒𝑙𝑠𝑒</m:t>
-                      </m:r>
-                      <m:r>
-                        <a:rPr lang="pt-BR" sz="2200" b="0" i="1" dirty="0" smtClean="0">
-                          <a:latin typeface="Cambria Math" panose="02040503050406030204" pitchFamily="18" charset="0"/>
-                        </a:rPr>
-                        <m:t> {</m:t>
-                      </m:r>
-                    </m:oMath>
-                  </m:oMathPara>
-                </a14:m>
-              </a:p>
-              <a:p>
-                <a:pPr marL="457200" lvl="1" indent="0">
-                  <a:buNone/>
-                </a:pPr>
-              </a:p>
-              <a:p>
-                <a:pPr marL="457200" lvl="1" indent="0">
-                  <a:buNone/>
-                </a:pPr>
-              </a:p>
-              <a:p>
-                <a:pPr marL="457200" lvl="1" indent="0">
-                  <a:buNone/>
-                </a:pPr>
-                <a:endParaRPr lang="pt-BR" sz="2200" b="0" i="1" dirty="0">
-                  <a:latin typeface="Cambria Math" panose="02040503050406030204" pitchFamily="18" charset="0"/>
-                </a:endParaRPr>
-              </a:p>
-              <a:p>
-                <a:pPr marL="457200" lvl="1" indent="0">
-                  <a:buNone/>
-                </a:pPr>
-                <a:r>
-                  <a:rPr lang="pt-BR" sz="2200" dirty="0"/>
-                  <a:t>       </a:t>
-                </a:r>
-                <a14:m>
-                  <m:oMath xmlns:m="http://schemas.openxmlformats.org/officeDocument/2006/math">
-                    <m:r>
-                      <a:rPr lang="pt-BR" sz="2200" i="1" dirty="0">
-                        <a:latin typeface="Cambria Math" panose="02040503050406030204" pitchFamily="18" charset="0"/>
-                      </a:rPr>
-                      <m:t>𝑏𝑙𝑜𝑐𝑜</m:t>
-                    </m:r>
-                    <m:r>
-                      <a:rPr lang="pt-BR" sz="2200" i="1" dirty="0">
-                        <a:latin typeface="Cambria Math" panose="02040503050406030204" pitchFamily="18" charset="0"/>
-                      </a:rPr>
-                      <m:t> </m:t>
-                    </m:r>
-                    <m:r>
-                      <a:rPr lang="pt-BR" sz="2200" i="1" dirty="0">
-                        <a:latin typeface="Cambria Math" panose="02040503050406030204" pitchFamily="18" charset="0"/>
-                      </a:rPr>
-                      <m:t>𝑑𝑒</m:t>
-                    </m:r>
-                    <m:r>
-                      <a:rPr lang="pt-BR" sz="2200" i="1" dirty="0">
-                        <a:latin typeface="Cambria Math" panose="02040503050406030204" pitchFamily="18" charset="0"/>
-                      </a:rPr>
-                      <m:t> </m:t>
-                    </m:r>
-                    <m:r>
-                      <a:rPr lang="pt-BR" sz="2200" i="1" dirty="0">
-                        <a:latin typeface="Cambria Math" panose="02040503050406030204" pitchFamily="18" charset="0"/>
-                      </a:rPr>
-                      <m:t>𝑐𝑜𝑚𝑎𝑛𝑑𝑜</m:t>
-                    </m:r>
-                    <m:r>
-                      <a:rPr lang="pt-BR" sz="2200" b="0" i="1" dirty="0" smtClean="0">
-                        <a:latin typeface="Cambria Math" panose="02040503050406030204" pitchFamily="18" charset="0"/>
-                      </a:rPr>
-                      <m:t>2</m:t>
-                    </m:r>
-                  </m:oMath>
-                </a14:m>
-                <a:endParaRPr lang="pt-BR" sz="2200" i="1" dirty="0">
-                  <a:latin typeface="Cambria Math" panose="02040503050406030204" pitchFamily="18" charset="0"/>
-                </a:endParaRPr>
-              </a:p>
-              <a:p>
-                <a:pPr marL="457200" lvl="1" indent="0">
-                  <a:buNone/>
-                </a:pPr>
-                <a14:m>
-                  <m:oMathPara xmlns:m="http://schemas.openxmlformats.org/officeDocument/2006/math">
-                    <m:oMathParaPr>
-                      <m:jc m:val="left"/>
-                    </m:oMathParaPr>
-                    <m:oMath xmlns:m="http://schemas.openxmlformats.org/officeDocument/2006/math">
-                      <m:r>
-                        <a:rPr lang="pt-BR" sz="2200" i="1" dirty="0" smtClean="0">
-                          <a:latin typeface="Cambria Math" panose="02040503050406030204" pitchFamily="18" charset="0"/>
-                        </a:rPr>
-                        <m:t>}</m:t>
-                      </m:r>
-                    </m:oMath>
-                  </m:oMathPara>
-                </a14:m>
-              </a:p>
-              <a:p>
-                <a:pPr marL="0" indent="0">
-                  <a:buNone/>
-                </a:pPr>
-                <a:endParaRPr lang="pt-BR" sz="2400" dirty="0"/>
-              </a:p>
-              <a:p>
-                <a:pPr lvl="1"/>
-                <a:endParaRPr lang="pt-BR" sz="2000" b="1" i="1" dirty="0"/>
-              </a:p>
-              <a:p>
-                <a:pPr lvl="1"/>
-                <a:endParaRPr lang="pt-BR" sz="2000" b="1" i="1" dirty="0"/>
-              </a:p>
-              <a:p>
-                <a:pPr lvl="1"/>
-                <a:endParaRPr lang="pt-BR" sz="1800" b="1" i="1" dirty="0"/>
-              </a:p>
-              <a:p>
-                <a:pPr lvl="1"/>
-                <a:endParaRPr lang="pt-BR" sz="1800" b="1" i="1" dirty="0"/>
-              </a:p>
-            </p:txBody>
-          </p:sp>
-        </mc:Choice>
-        <mc:Fallback>
-          <p:sp>
-            <p:nvSpPr>
-              <p:cNvPr id="6" name="Espaço Reservado para Conteúdo 5">
-                <a:extLst>
-                  <a:ext uri="{FF2B5EF4-FFF2-40B4-BE49-F238E27FC236}">
-                    <a16:creationId xmlns:a16="http://schemas.microsoft.com/office/drawing/2014/main" id="{402F2442-8B72-6182-8933-F74EC87244EE}"/>
-                  </a:ext>
-                </a:extLst>
-              </p:cNvPr>
-              <p:cNvSpPr>
-                <a:spLocks noGrp="1" noRot="1" noChangeAspect="1" noMove="1" noResize="1" noEditPoints="1" noAdjustHandles="1" noChangeArrowheads="1" noChangeShapeType="1" noTextEdit="1"/>
-              </p:cNvSpPr>
-              <p:nvPr>
-                <p:ph idx="1"/>
-              </p:nvPr>
-            </p:nvSpPr>
-            <p:spPr>
-              <a:xfrm>
-                <a:off x="1692363" y="1552668"/>
-                <a:ext cx="10014215" cy="5305332"/>
-              </a:xfrm>
-              <a:blipFill>
-                <a:blip r:embed="rId3"/>
-                <a:stretch>
-                  <a:fillRect l="-853" t="-1609" r="-305"/>
-                </a:stretch>
-              </a:blipFill>
-            </p:spPr>
-            <p:txBody>
-              <a:bodyPr/>
-              <a:lstStyle/>
-              <a:p>
-                <a:r>
-                  <a:rPr lang="pt-BR">
-                    <a:noFill/>
-                  </a:rPr>
-                  <a:t> </a:t>
-                </a:r>
-              </a:p>
-            </p:txBody>
-          </p:sp>
-        </mc:Fallback>
-      </mc:AlternateContent>
+      <p:sp>
+        <p:nvSpPr>
+          <p:cNvPr id="6" name="Espaço Reservado para Conteúdo 5">
+            <a:extLst>
+              <a:ext uri="{FF2B5EF4-FFF2-40B4-BE49-F238E27FC236}">
+                <a16:creationId xmlns:a16="http://schemas.microsoft.com/office/drawing/2014/main" id="{402F2442-8B72-6182-8933-F74EC87244EE}"/>
+              </a:ext>
+            </a:extLst>
+          </p:cNvPr>
+          <p:cNvSpPr>
+            <a:spLocks noGrp="1"/>
+          </p:cNvSpPr>
+          <p:nvPr>
+            <p:ph idx="1"/>
+          </p:nvPr>
+        </p:nvSpPr>
+        <p:spPr>
+          <a:xfrm>
+            <a:off x="1692363" y="1552668"/>
+            <a:ext cx="10014215" cy="5305332"/>
+          </a:xfrm>
+        </p:spPr>
+        <p:txBody>
+          <a:bodyPr>
+            <a:normAutofit/>
+          </a:bodyPr>
+          <a:lstStyle/>
+          <a:p>
+            <a:r>
+              <a:rPr lang="pt-BR" sz="2400" dirty="0"/>
+              <a:t>Análogo ao SE-ENTÃO-SENÃO do Visual G.</a:t>
+            </a:r>
+          </a:p>
+          <a:p>
+            <a:r>
+              <a:rPr lang="pt-BR" sz="2400" dirty="0"/>
+              <a:t>A execução de um determinado trecho é executada somente se a condição for satisfeita.</a:t>
+            </a:r>
+          </a:p>
+          <a:p>
+            <a:r>
+              <a:rPr lang="pt-BR" sz="2400" dirty="0"/>
+              <a:t>Caso a condição não seja satisfeita, um outro bloco de comando é executado.</a:t>
+            </a:r>
+          </a:p>
+          <a:p>
+            <a:endParaRPr lang="pt-BR" sz="2400" dirty="0"/>
+          </a:p>
+          <a:p>
+            <a:pPr marL="0" indent="0">
+              <a:buNone/>
+            </a:pPr>
+            <a:endParaRPr lang="pt-BR" sz="2400" dirty="0"/>
+          </a:p>
+          <a:p>
+            <a:pPr lvl="1"/>
+            <a:endParaRPr lang="pt-BR" sz="2000" b="1" i="1" dirty="0"/>
+          </a:p>
+          <a:p>
+            <a:pPr lvl="1"/>
+            <a:endParaRPr lang="pt-BR" sz="2000" b="1" i="1" dirty="0"/>
+          </a:p>
+          <a:p>
+            <a:pPr lvl="1"/>
+            <a:endParaRPr lang="pt-BR" sz="1800" b="1" i="1" dirty="0"/>
+          </a:p>
+          <a:p>
+            <a:pPr lvl="1"/>
+            <a:endParaRPr lang="pt-BR" sz="1800" b="1" i="1" dirty="0"/>
+          </a:p>
+        </p:txBody>
+      </p:sp>
       <p:pic>
         <p:nvPicPr>
           <p:cNvPr id="4" name="Imagem 3">
             <a:extLst>
               <a:ext uri="{FF2B5EF4-FFF2-40B4-BE49-F238E27FC236}">
                 <a16:creationId xmlns:a16="http://schemas.microsoft.com/office/drawing/2014/main" id="{08DCCD08-AE7D-C0FC-C117-533B198ED397}"/>
+              </a:ext>
+            </a:extLst>
+          </p:cNvPr>
+          <p:cNvPicPr>
+            <a:picLocks noChangeAspect="1"/>
+          </p:cNvPicPr>
+          <p:nvPr/>
+        </p:nvPicPr>
+        <p:blipFill>
+          <a:blip r:embed="rId3"/>
+          <a:stretch>
+            <a:fillRect/>
+          </a:stretch>
+        </p:blipFill>
+        <p:spPr>
+          <a:xfrm>
+            <a:off x="6824619" y="3581400"/>
+            <a:ext cx="3850481" cy="3103373"/>
+          </a:xfrm>
+          <a:prstGeom prst="rect">
+            <a:avLst/>
+          </a:prstGeom>
+        </p:spPr>
+      </p:pic>
+      <p:pic>
+        <p:nvPicPr>
+          <p:cNvPr id="7" name="Imagem 6">
+            <a:extLst>
+              <a:ext uri="{FF2B5EF4-FFF2-40B4-BE49-F238E27FC236}">
+                <a16:creationId xmlns:a16="http://schemas.microsoft.com/office/drawing/2014/main" id="{73244BE0-763F-2D6E-6265-077359D6DAE7}"/>
               </a:ext>
             </a:extLst>
           </p:cNvPr>
@@ -30983,8 +30486,8 @@
         </p:blipFill>
         <p:spPr>
           <a:xfrm>
-            <a:off x="6220817" y="3429000"/>
-            <a:ext cx="4278820" cy="3448602"/>
+            <a:off x="1990882" y="3418586"/>
+            <a:ext cx="3654200" cy="3429000"/>
           </a:xfrm>
           <a:prstGeom prst="rect">
             <a:avLst/>
@@ -31164,511 +30667,115 @@
           </a:p>
         </p:txBody>
       </p:sp>
-      <mc:AlternateContent xmlns:mc="http://schemas.openxmlformats.org/markup-compatibility/2006">
-        <mc:Choice xmlns:a14="http://schemas.microsoft.com/office/drawing/2010/main" Requires="a14">
-          <p:sp>
-            <p:nvSpPr>
-              <p:cNvPr id="6" name="Espaço Reservado para Conteúdo 5">
-                <a:extLst>
-                  <a:ext uri="{FF2B5EF4-FFF2-40B4-BE49-F238E27FC236}">
-                    <a16:creationId xmlns:a16="http://schemas.microsoft.com/office/drawing/2014/main" id="{C1F72C18-3515-7C50-83DD-9052A8D9197F}"/>
-                  </a:ext>
-                </a:extLst>
-              </p:cNvPr>
-              <p:cNvSpPr>
-                <a:spLocks noGrp="1"/>
-              </p:cNvSpPr>
-              <p:nvPr>
-                <p:ph idx="1"/>
-              </p:nvPr>
-            </p:nvSpPr>
-            <p:spPr>
-              <a:xfrm>
-                <a:off x="598266" y="1451068"/>
-                <a:ext cx="7293107" cy="5305332"/>
-              </a:xfrm>
-            </p:spPr>
-            <p:txBody>
-              <a:bodyPr>
-                <a:normAutofit/>
-              </a:bodyPr>
-              <a:lstStyle/>
-              <a:p>
-                <a:r>
-                  <a:rPr lang="pt-BR" sz="2400" dirty="0"/>
-                  <a:t>Caso existam múltiplas condições à serem analisadas, os operadores de </a:t>
-                </a:r>
-                <a:r>
-                  <a:rPr lang="pt-BR" sz="2400" b="1" i="1" dirty="0" err="1"/>
-                  <a:t>if</a:t>
-                </a:r>
-                <a:r>
-                  <a:rPr lang="pt-BR" sz="2400" dirty="0"/>
-                  <a:t> e </a:t>
-                </a:r>
-                <a:r>
-                  <a:rPr lang="pt-BR" sz="2400" b="1" i="1" dirty="0" err="1"/>
-                  <a:t>else</a:t>
-                </a:r>
-                <a:r>
-                  <a:rPr lang="pt-BR" sz="2400" dirty="0"/>
-                  <a:t> podem ser encadeados sequencialmente</a:t>
-                </a:r>
-              </a:p>
-              <a:p>
-                <a:endParaRPr lang="pt-BR" sz="2400" dirty="0"/>
-              </a:p>
-              <a:p>
-                <a:r>
-                  <a:rPr lang="pt-BR" sz="2400" dirty="0"/>
-                  <a:t>Sintaxe do encadeamento:</a:t>
-                </a:r>
-              </a:p>
-              <a:p>
-                <a:endParaRPr lang="pt-BR" sz="2400" dirty="0"/>
-              </a:p>
-              <a:p>
-                <a:pPr marL="457200" lvl="1" indent="0">
-                  <a:buNone/>
-                </a:pPr>
-                <a14:m>
-                  <m:oMathPara xmlns:m="http://schemas.openxmlformats.org/officeDocument/2006/math">
-                    <m:oMathParaPr>
-                      <m:jc m:val="left"/>
-                    </m:oMathParaPr>
-                    <m:oMath xmlns:m="http://schemas.openxmlformats.org/officeDocument/2006/math">
-                      <m:r>
-                        <a:rPr lang="pt-BR" sz="2200" i="1" dirty="0" smtClean="0">
-                          <a:latin typeface="Cambria Math" panose="02040503050406030204" pitchFamily="18" charset="0"/>
-                        </a:rPr>
-                        <m:t>𝐼𝑓</m:t>
-                      </m:r>
-                      <m:r>
-                        <a:rPr lang="pt-BR" sz="2200" i="1" dirty="0" smtClean="0">
-                          <a:latin typeface="Cambria Math" panose="02040503050406030204" pitchFamily="18" charset="0"/>
-                        </a:rPr>
-                        <m:t>(</m:t>
-                      </m:r>
-                      <m:r>
-                        <a:rPr lang="pt-BR" sz="2200" i="1" dirty="0" smtClean="0">
-                          <a:latin typeface="Cambria Math" panose="02040503050406030204" pitchFamily="18" charset="0"/>
-                        </a:rPr>
-                        <m:t>𝑐𝑜𝑛𝑑𝑖</m:t>
-                      </m:r>
-                      <m:r>
-                        <a:rPr lang="pt-BR" sz="2200" i="1" dirty="0" smtClean="0">
-                          <a:latin typeface="Cambria Math" panose="02040503050406030204" pitchFamily="18" charset="0"/>
-                        </a:rPr>
-                        <m:t>çã</m:t>
-                      </m:r>
-                      <m:r>
-                        <a:rPr lang="pt-BR" sz="2200" i="1" dirty="0" smtClean="0">
-                          <a:latin typeface="Cambria Math" panose="02040503050406030204" pitchFamily="18" charset="0"/>
-                        </a:rPr>
-                        <m:t>𝑜</m:t>
-                      </m:r>
-                      <m:r>
-                        <a:rPr lang="pt-BR" sz="2200" i="1" dirty="0" smtClean="0">
-                          <a:latin typeface="Cambria Math" panose="02040503050406030204" pitchFamily="18" charset="0"/>
-                        </a:rPr>
-                        <m:t>){</m:t>
-                      </m:r>
-                    </m:oMath>
-                  </m:oMathPara>
-                  <m:oMathPara xmlns:m="http://schemas.openxmlformats.org/officeDocument/2006/math">
-                    <m:oMathParaPr>
-                      <m:jc m:val="left"/>
-                    </m:oMathParaPr>
-                    <m:oMath xmlns:m="http://schemas.openxmlformats.org/officeDocument/2006/math">
-                      <m:r>
-                        <a:rPr lang="pt-BR" sz="2200" i="1" dirty="0" smtClean="0">
-                          <a:latin typeface="Cambria Math" panose="02040503050406030204" pitchFamily="18" charset="0"/>
-                        </a:rPr>
-                        <m:t>	</m:t>
-                      </m:r>
-                      <m:r>
-                        <a:rPr lang="pt-BR" sz="2200" b="0" i="1" dirty="0" smtClean="0">
-                          <a:latin typeface="Cambria Math" panose="02040503050406030204" pitchFamily="18" charset="0"/>
-                        </a:rPr>
-                        <m:t>      </m:t>
-                      </m:r>
-                      <m:r>
-                        <a:rPr lang="pt-BR" sz="2200" i="1" dirty="0" smtClean="0">
-                          <a:latin typeface="Cambria Math" panose="02040503050406030204" pitchFamily="18" charset="0"/>
-                        </a:rPr>
-                        <m:t>𝑏𝑙𝑜𝑐𝑜</m:t>
-                      </m:r>
-                      <m:r>
-                        <a:rPr lang="pt-BR" sz="2200" i="1" dirty="0" smtClean="0">
-                          <a:latin typeface="Cambria Math" panose="02040503050406030204" pitchFamily="18" charset="0"/>
-                        </a:rPr>
-                        <m:t> </m:t>
-                      </m:r>
-                      <m:r>
-                        <a:rPr lang="pt-BR" sz="2200" i="1" dirty="0" smtClean="0">
-                          <a:latin typeface="Cambria Math" panose="02040503050406030204" pitchFamily="18" charset="0"/>
-                        </a:rPr>
-                        <m:t>𝑑𝑒</m:t>
-                      </m:r>
-                      <m:r>
-                        <a:rPr lang="pt-BR" sz="2200" i="1" dirty="0" smtClean="0">
-                          <a:latin typeface="Cambria Math" panose="02040503050406030204" pitchFamily="18" charset="0"/>
-                        </a:rPr>
-                        <m:t> </m:t>
-                      </m:r>
-                      <m:r>
-                        <a:rPr lang="pt-BR" sz="2200" i="1" dirty="0" smtClean="0">
-                          <a:latin typeface="Cambria Math" panose="02040503050406030204" pitchFamily="18" charset="0"/>
-                        </a:rPr>
-                        <m:t>𝑐𝑜𝑚𝑎𝑛𝑑𝑜</m:t>
-                      </m:r>
-                      <m:r>
-                        <a:rPr lang="pt-BR" sz="2200" b="0" i="1" dirty="0" smtClean="0">
-                          <a:latin typeface="Cambria Math" panose="02040503050406030204" pitchFamily="18" charset="0"/>
-                        </a:rPr>
-                        <m:t> 1</m:t>
-                      </m:r>
-                    </m:oMath>
-                  </m:oMathPara>
-                  <m:oMathPara xmlns:m="http://schemas.openxmlformats.org/officeDocument/2006/math">
-                    <m:oMathParaPr>
-                      <m:jc m:val="left"/>
-                    </m:oMathParaPr>
-                    <m:oMath xmlns:m="http://schemas.openxmlformats.org/officeDocument/2006/math">
-                      <m:r>
-                        <a:rPr lang="pt-BR" sz="2200" i="1" dirty="0" smtClean="0">
-                          <a:latin typeface="Cambria Math" panose="02040503050406030204" pitchFamily="18" charset="0"/>
-                        </a:rPr>
-                        <m:t>}</m:t>
-                      </m:r>
-                      <m:r>
-                        <a:rPr lang="pt-BR" sz="2200" b="0" i="1" dirty="0" smtClean="0">
-                          <a:latin typeface="Cambria Math" panose="02040503050406030204" pitchFamily="18" charset="0"/>
-                        </a:rPr>
-                        <m:t> </m:t>
-                      </m:r>
-                      <m:r>
-                        <a:rPr lang="pt-BR" sz="2200" b="0" i="1" dirty="0" smtClean="0">
-                          <a:latin typeface="Cambria Math" panose="02040503050406030204" pitchFamily="18" charset="0"/>
-                        </a:rPr>
-                        <m:t>𝑒𝑙𝑠𝑒</m:t>
-                      </m:r>
-                      <m:r>
-                        <a:rPr lang="pt-BR" sz="2200" b="0" i="1" dirty="0" smtClean="0">
-                          <a:latin typeface="Cambria Math" panose="02040503050406030204" pitchFamily="18" charset="0"/>
-                        </a:rPr>
-                        <m:t> </m:t>
-                      </m:r>
-                      <m:r>
-                        <a:rPr lang="pt-BR" sz="2200" b="0" i="1" dirty="0" smtClean="0">
-                          <a:latin typeface="Cambria Math" panose="02040503050406030204" pitchFamily="18" charset="0"/>
-                        </a:rPr>
-                        <m:t>𝑖𝑓</m:t>
-                      </m:r>
-                      <m:r>
-                        <a:rPr lang="pt-BR" sz="2200" i="1" dirty="0">
-                          <a:latin typeface="Cambria Math" panose="02040503050406030204" pitchFamily="18" charset="0"/>
-                        </a:rPr>
-                        <m:t>(</m:t>
-                      </m:r>
-                      <m:r>
-                        <a:rPr lang="pt-BR" sz="2200" i="1" dirty="0">
-                          <a:latin typeface="Cambria Math" panose="02040503050406030204" pitchFamily="18" charset="0"/>
-                        </a:rPr>
-                        <m:t>𝑐𝑜𝑛𝑑𝑖</m:t>
-                      </m:r>
-                      <m:r>
-                        <a:rPr lang="pt-BR" sz="2200" i="1" dirty="0">
-                          <a:latin typeface="Cambria Math" panose="02040503050406030204" pitchFamily="18" charset="0"/>
-                        </a:rPr>
-                        <m:t>çã</m:t>
-                      </m:r>
-                      <m:r>
-                        <a:rPr lang="pt-BR" sz="2200" i="1" dirty="0">
-                          <a:latin typeface="Cambria Math" panose="02040503050406030204" pitchFamily="18" charset="0"/>
-                        </a:rPr>
-                        <m:t>𝑜</m:t>
-                      </m:r>
-                      <m:r>
-                        <a:rPr lang="pt-BR" sz="2200" i="1" dirty="0">
-                          <a:latin typeface="Cambria Math" panose="02040503050406030204" pitchFamily="18" charset="0"/>
-                        </a:rPr>
-                        <m:t>){</m:t>
-                      </m:r>
-                    </m:oMath>
-                  </m:oMathPara>
-                </a14:m>
-              </a:p>
-              <a:p>
-                <a:pPr marL="457200" lvl="1" indent="0">
-                  <a:buNone/>
-                </a:pPr>
-              </a:p>
-              <a:p>
-                <a:pPr marL="457200" lvl="1" indent="0">
-                  <a:buNone/>
-                </a:pPr>
-                <a:endParaRPr lang="pt-BR" sz="2200" b="0" i="1" dirty="0">
-                  <a:latin typeface="Cambria Math" panose="02040503050406030204" pitchFamily="18" charset="0"/>
-                </a:endParaRPr>
-              </a:p>
-              <a:p>
-                <a:pPr marL="457200" lvl="1" indent="0">
-                  <a:buNone/>
-                </a:pPr>
-                <a:r>
-                  <a:rPr lang="pt-BR" sz="2200" dirty="0"/>
-                  <a:t>       </a:t>
-                </a:r>
-                <a14:m>
-                  <m:oMath xmlns:m="http://schemas.openxmlformats.org/officeDocument/2006/math">
-                    <m:r>
-                      <a:rPr lang="pt-BR" sz="2200" i="1" dirty="0">
-                        <a:latin typeface="Cambria Math" panose="02040503050406030204" pitchFamily="18" charset="0"/>
-                      </a:rPr>
-                      <m:t>𝑏𝑙𝑜𝑐𝑜</m:t>
-                    </m:r>
-                    <m:r>
-                      <a:rPr lang="pt-BR" sz="2200" i="1" dirty="0">
-                        <a:latin typeface="Cambria Math" panose="02040503050406030204" pitchFamily="18" charset="0"/>
-                      </a:rPr>
-                      <m:t> </m:t>
-                    </m:r>
-                    <m:r>
-                      <a:rPr lang="pt-BR" sz="2200" i="1" dirty="0">
-                        <a:latin typeface="Cambria Math" panose="02040503050406030204" pitchFamily="18" charset="0"/>
-                      </a:rPr>
-                      <m:t>𝑑𝑒</m:t>
-                    </m:r>
-                    <m:r>
-                      <a:rPr lang="pt-BR" sz="2200" i="1" dirty="0">
-                        <a:latin typeface="Cambria Math" panose="02040503050406030204" pitchFamily="18" charset="0"/>
-                      </a:rPr>
-                      <m:t> </m:t>
-                    </m:r>
-                    <m:r>
-                      <a:rPr lang="pt-BR" sz="2200" i="1" dirty="0">
-                        <a:latin typeface="Cambria Math" panose="02040503050406030204" pitchFamily="18" charset="0"/>
-                      </a:rPr>
-                      <m:t>𝑐𝑜𝑚𝑎𝑛𝑑𝑜</m:t>
-                    </m:r>
-                    <m:r>
-                      <a:rPr lang="pt-BR" sz="2200" b="0" i="1" dirty="0" smtClean="0">
-                        <a:latin typeface="Cambria Math" panose="02040503050406030204" pitchFamily="18" charset="0"/>
-                      </a:rPr>
-                      <m:t> 2</m:t>
-                    </m:r>
-                  </m:oMath>
-                </a14:m>
-                <a:endParaRPr lang="pt-BR" sz="2200" i="1" dirty="0">
-                  <a:latin typeface="Cambria Math" panose="02040503050406030204" pitchFamily="18" charset="0"/>
-                </a:endParaRPr>
-              </a:p>
-              <a:p>
-                <a:pPr marL="457200" lvl="1" indent="0">
-                  <a:buNone/>
-                </a:pPr>
-                <a14:m>
-                  <m:oMathPara xmlns:m="http://schemas.openxmlformats.org/officeDocument/2006/math">
-                    <m:oMathParaPr>
-                      <m:jc m:val="left"/>
-                    </m:oMathParaPr>
-                    <m:oMath xmlns:m="http://schemas.openxmlformats.org/officeDocument/2006/math">
-                      <m:r>
-                        <a:rPr lang="pt-BR" sz="2200" i="1" dirty="0" smtClean="0">
-                          <a:latin typeface="Cambria Math" panose="02040503050406030204" pitchFamily="18" charset="0"/>
-                        </a:rPr>
-                        <m:t>…</m:t>
-                      </m:r>
-                    </m:oMath>
-                  </m:oMathPara>
-                </a14:m>
-                <a:endParaRPr lang="pt-BR" sz="2200" i="1" dirty="0">
-                  <a:latin typeface="Cambria Math" panose="02040503050406030204" pitchFamily="18" charset="0"/>
-                </a:endParaRPr>
-              </a:p>
-              <a:p>
-                <a:pPr marL="457200" lvl="1" indent="0">
-                  <a:buNone/>
-                </a:pPr>
-                <a14:m>
-                  <m:oMathPara xmlns:m="http://schemas.openxmlformats.org/officeDocument/2006/math">
-                    <m:oMathParaPr>
-                      <m:jc m:val="left"/>
-                    </m:oMathParaPr>
-                    <m:oMath xmlns:m="http://schemas.openxmlformats.org/officeDocument/2006/math">
-                      <m:r>
-                        <a:rPr lang="pt-BR" sz="2200" i="1" dirty="0">
-                          <a:latin typeface="Cambria Math" panose="02040503050406030204" pitchFamily="18" charset="0"/>
-                        </a:rPr>
-                        <m:t>}</m:t>
-                      </m:r>
-                      <m:r>
-                        <m:rPr>
-                          <m:sty m:val="p"/>
-                        </m:rPr>
-                        <a:rPr lang="pt-BR" sz="2200" b="0" i="0" dirty="0" smtClean="0">
-                          <a:latin typeface="Cambria Math" panose="02040503050406030204" pitchFamily="18" charset="0"/>
-                        </a:rPr>
-                        <m:t>else</m:t>
-                      </m:r>
-                      <m:r>
-                        <a:rPr lang="pt-BR" sz="2200" b="0" i="0" dirty="0" smtClean="0">
-                          <a:latin typeface="Cambria Math" panose="02040503050406030204" pitchFamily="18" charset="0"/>
-                        </a:rPr>
-                        <m:t> {</m:t>
-                      </m:r>
-                    </m:oMath>
-                  </m:oMathPara>
-                </a14:m>
-                <a:endParaRPr lang="pt-BR" sz="2200" b="0" dirty="0"/>
-              </a:p>
-              <a:p>
-                <a:pPr marL="457200" lvl="1" indent="0">
-                  <a:buNone/>
-                </a:pPr>
-                <a:r>
-                  <a:rPr lang="pt-BR" sz="2200" dirty="0"/>
-                  <a:t>      </a:t>
-                </a:r>
-                <a14:m>
-                  <m:oMath xmlns:m="http://schemas.openxmlformats.org/officeDocument/2006/math">
-                    <m:r>
-                      <a:rPr lang="pt-BR" sz="2200" i="1" dirty="0">
-                        <a:latin typeface="Cambria Math" panose="02040503050406030204" pitchFamily="18" charset="0"/>
-                      </a:rPr>
-                      <m:t>𝑏𝑙𝑜𝑐𝑜</m:t>
-                    </m:r>
-                    <m:r>
-                      <a:rPr lang="pt-BR" sz="2200" i="1" dirty="0">
-                        <a:latin typeface="Cambria Math" panose="02040503050406030204" pitchFamily="18" charset="0"/>
-                      </a:rPr>
-                      <m:t> </m:t>
-                    </m:r>
-                    <m:r>
-                      <a:rPr lang="pt-BR" sz="2200" i="1" dirty="0">
-                        <a:latin typeface="Cambria Math" panose="02040503050406030204" pitchFamily="18" charset="0"/>
-                      </a:rPr>
-                      <m:t>𝑑𝑒</m:t>
-                    </m:r>
-                    <m:r>
-                      <a:rPr lang="pt-BR" sz="2200" i="1" dirty="0">
-                        <a:latin typeface="Cambria Math" panose="02040503050406030204" pitchFamily="18" charset="0"/>
-                      </a:rPr>
-                      <m:t> </m:t>
-                    </m:r>
-                    <m:r>
-                      <a:rPr lang="pt-BR" sz="2200" i="1" dirty="0">
-                        <a:latin typeface="Cambria Math" panose="02040503050406030204" pitchFamily="18" charset="0"/>
-                      </a:rPr>
-                      <m:t>𝑐𝑜𝑚𝑎𝑛𝑑𝑜</m:t>
-                    </m:r>
-                    <m:r>
-                      <a:rPr lang="pt-BR" sz="2200" i="1" dirty="0">
-                        <a:latin typeface="Cambria Math" panose="02040503050406030204" pitchFamily="18" charset="0"/>
-                      </a:rPr>
-                      <m:t> </m:t>
-                    </m:r>
-                    <m:r>
-                      <a:rPr lang="pt-BR" sz="2200" b="0" i="1" dirty="0" smtClean="0">
-                        <a:latin typeface="Cambria Math" panose="02040503050406030204" pitchFamily="18" charset="0"/>
-                      </a:rPr>
-                      <m:t>𝑓𝑖𝑛𝑎𝑙</m:t>
-                    </m:r>
-                  </m:oMath>
-                </a14:m>
-                <a:endParaRPr lang="pt-BR" sz="2200" dirty="0"/>
-              </a:p>
-              <a:p>
-                <a:pPr marL="457200" lvl="1" indent="0">
-                  <a:buNone/>
-                </a:pPr>
-                <a:r>
-                  <a:rPr lang="pt-BR" sz="2200" dirty="0"/>
-                  <a:t>}</a:t>
-                </a:r>
-              </a:p>
-              <a:p>
-                <a:pPr marL="457200" lvl="1" indent="0">
-                  <a:buNone/>
-                </a:pPr>
-                <a14:m/>
-              </a:p>
-              <a:p>
-                <a:pPr marL="0" indent="0">
-                  <a:buNone/>
-                </a:pPr>
-                <a:endParaRPr lang="pt-BR" sz="2400" dirty="0"/>
-              </a:p>
-              <a:p>
-                <a:pPr lvl="1"/>
-                <a:endParaRPr lang="pt-BR" sz="2000" b="1" i="1" dirty="0"/>
-              </a:p>
-              <a:p>
-                <a:pPr lvl="1"/>
-                <a:endParaRPr lang="pt-BR" sz="2000" b="1" i="1" dirty="0"/>
-              </a:p>
-              <a:p>
-                <a:pPr lvl="1"/>
-                <a:endParaRPr lang="pt-BR" sz="1800" b="1" i="1" dirty="0"/>
-              </a:p>
-              <a:p>
-                <a:pPr lvl="1"/>
-                <a:endParaRPr lang="pt-BR" sz="1800" b="1" i="1" dirty="0"/>
-              </a:p>
-            </p:txBody>
-          </p:sp>
-        </mc:Choice>
-        <mc:Fallback>
-          <p:sp>
-            <p:nvSpPr>
-              <p:cNvPr id="6" name="Espaço Reservado para Conteúdo 5">
-                <a:extLst>
-                  <a:ext uri="{FF2B5EF4-FFF2-40B4-BE49-F238E27FC236}">
-                    <a16:creationId xmlns:a16="http://schemas.microsoft.com/office/drawing/2014/main" id="{C1F72C18-3515-7C50-83DD-9052A8D9197F}"/>
-                  </a:ext>
-                </a:extLst>
-              </p:cNvPr>
-              <p:cNvSpPr>
-                <a:spLocks noGrp="1" noRot="1" noChangeAspect="1" noMove="1" noResize="1" noEditPoints="1" noAdjustHandles="1" noChangeArrowheads="1" noChangeShapeType="1" noTextEdit="1"/>
-              </p:cNvSpPr>
-              <p:nvPr>
-                <p:ph idx="1"/>
-              </p:nvPr>
-            </p:nvSpPr>
-            <p:spPr>
-              <a:xfrm>
-                <a:off x="598266" y="1451068"/>
-                <a:ext cx="7293107" cy="5305332"/>
-              </a:xfrm>
-              <a:blipFill>
-                <a:blip r:embed="rId3"/>
-                <a:stretch>
-                  <a:fillRect l="-1086" t="-1609"/>
-                </a:stretch>
-              </a:blipFill>
-            </p:spPr>
-            <p:txBody>
-              <a:bodyPr/>
-              <a:lstStyle/>
-              <a:p>
-                <a:r>
-                  <a:rPr lang="pt-BR">
-                    <a:noFill/>
-                  </a:rPr>
-                  <a:t> </a:t>
-                </a:r>
-              </a:p>
-            </p:txBody>
-          </p:sp>
-        </mc:Fallback>
-      </mc:AlternateContent>
+      <p:sp>
+        <p:nvSpPr>
+          <p:cNvPr id="6" name="Espaço Reservado para Conteúdo 5">
+            <a:extLst>
+              <a:ext uri="{FF2B5EF4-FFF2-40B4-BE49-F238E27FC236}">
+                <a16:creationId xmlns:a16="http://schemas.microsoft.com/office/drawing/2014/main" id="{C1F72C18-3515-7C50-83DD-9052A8D9197F}"/>
+              </a:ext>
+            </a:extLst>
+          </p:cNvPr>
+          <p:cNvSpPr>
+            <a:spLocks noGrp="1"/>
+          </p:cNvSpPr>
+          <p:nvPr>
+            <p:ph idx="1"/>
+          </p:nvPr>
+        </p:nvSpPr>
+        <p:spPr>
+          <a:xfrm>
+            <a:off x="959224" y="1896755"/>
+            <a:ext cx="5655778" cy="4413955"/>
+          </a:xfrm>
+        </p:spPr>
+        <p:txBody>
+          <a:bodyPr>
+            <a:normAutofit/>
+          </a:bodyPr>
+          <a:lstStyle/>
+          <a:p>
+            <a:r>
+              <a:rPr lang="pt-BR" sz="2400" dirty="0"/>
+              <a:t>Caso existam múltiplas condições à serem analisadas, os operadores de </a:t>
+            </a:r>
+            <a:r>
+              <a:rPr lang="pt-BR" sz="2400" b="1" i="1" dirty="0" err="1"/>
+              <a:t>if</a:t>
+            </a:r>
+            <a:r>
+              <a:rPr lang="pt-BR" sz="2400" dirty="0"/>
+              <a:t> e </a:t>
+            </a:r>
+            <a:r>
+              <a:rPr lang="pt-BR" sz="2400" b="1" i="1" dirty="0" err="1"/>
+              <a:t>else</a:t>
+            </a:r>
+            <a:r>
+              <a:rPr lang="pt-BR" sz="2400" dirty="0"/>
+              <a:t> podem ser encadeados sequencialmente.</a:t>
+            </a:r>
+          </a:p>
+          <a:p>
+            <a:endParaRPr lang="pt-BR" sz="2400" dirty="0"/>
+          </a:p>
+          <a:p>
+            <a:endParaRPr lang="pt-BR" sz="2400" dirty="0"/>
+          </a:p>
+          <a:p>
+            <a:pPr lvl="1"/>
+            <a:endParaRPr lang="pt-BR" sz="2000" b="1" i="1" dirty="0"/>
+          </a:p>
+          <a:p>
+            <a:pPr lvl="1"/>
+            <a:endParaRPr lang="pt-BR" sz="2000" b="1" i="1" dirty="0"/>
+          </a:p>
+          <a:p>
+            <a:pPr lvl="1"/>
+            <a:endParaRPr lang="pt-BR" sz="1800" b="1" i="1" dirty="0"/>
+          </a:p>
+          <a:p>
+            <a:pPr lvl="1"/>
+            <a:endParaRPr lang="pt-BR" sz="1800" b="1" i="1" dirty="0"/>
+          </a:p>
+        </p:txBody>
+      </p:sp>
       <p:pic>
         <p:nvPicPr>
           <p:cNvPr id="9" name="Imagem 8">
             <a:extLst>
               <a:ext uri="{FF2B5EF4-FFF2-40B4-BE49-F238E27FC236}">
                 <a16:creationId xmlns:a16="http://schemas.microsoft.com/office/drawing/2014/main" id="{932AAEF5-AEDA-5984-A95D-1EA112776BE7}"/>
+              </a:ext>
+            </a:extLst>
+          </p:cNvPr>
+          <p:cNvPicPr>
+            <a:picLocks noChangeAspect="1"/>
+          </p:cNvPicPr>
+          <p:nvPr/>
+        </p:nvPicPr>
+        <p:blipFill>
+          <a:blip r:embed="rId3"/>
+          <a:stretch>
+            <a:fillRect/>
+          </a:stretch>
+        </p:blipFill>
+        <p:spPr>
+          <a:xfrm>
+            <a:off x="6880473" y="1451066"/>
+            <a:ext cx="4135580" cy="5305332"/>
+          </a:xfrm>
+          <a:prstGeom prst="rect">
+            <a:avLst/>
+          </a:prstGeom>
+        </p:spPr>
+      </p:pic>
+      <p:pic>
+        <p:nvPicPr>
+          <p:cNvPr id="3" name="Imagem 2">
+            <a:extLst>
+              <a:ext uri="{FF2B5EF4-FFF2-40B4-BE49-F238E27FC236}">
+                <a16:creationId xmlns:a16="http://schemas.microsoft.com/office/drawing/2014/main" id="{0F019E79-9DE9-561B-3CF0-648C2E8C0728}"/>
               </a:ext>
             </a:extLst>
           </p:cNvPr>
@@ -31685,14 +30792,66 @@
         </p:blipFill>
         <p:spPr>
           <a:xfrm>
-            <a:off x="7947181" y="1451068"/>
-            <a:ext cx="4135580" cy="5305332"/>
+            <a:off x="1224695" y="3176672"/>
+            <a:ext cx="5124835" cy="3538766"/>
           </a:xfrm>
           <a:prstGeom prst="rect">
             <a:avLst/>
           </a:prstGeom>
         </p:spPr>
       </p:pic>
+      <p:sp>
+        <p:nvSpPr>
+          <p:cNvPr id="4" name="Retângulo 3">
+            <a:extLst>
+              <a:ext uri="{FF2B5EF4-FFF2-40B4-BE49-F238E27FC236}">
+                <a16:creationId xmlns:a16="http://schemas.microsoft.com/office/drawing/2014/main" id="{77F2AE48-E24F-1212-3A7D-959C2235010C}"/>
+              </a:ext>
+            </a:extLst>
+          </p:cNvPr>
+          <p:cNvSpPr/>
+          <p:nvPr/>
+        </p:nvSpPr>
+        <p:spPr>
+          <a:xfrm>
+            <a:off x="4380089" y="3228622"/>
+            <a:ext cx="1896533" cy="530578"/>
+          </a:xfrm>
+          <a:prstGeom prst="rect">
+            <a:avLst/>
+          </a:prstGeom>
+          <a:solidFill>
+            <a:srgbClr val="7DA7D8"/>
+          </a:solidFill>
+          <a:ln>
+            <a:noFill/>
+          </a:ln>
+        </p:spPr>
+        <p:style>
+          <a:lnRef idx="2">
+            <a:schemeClr val="accent1">
+              <a:shade val="15000"/>
+            </a:schemeClr>
+          </a:lnRef>
+          <a:fillRef idx="1">
+            <a:schemeClr val="accent1"/>
+          </a:fillRef>
+          <a:effectRef idx="0">
+            <a:schemeClr val="accent1"/>
+          </a:effectRef>
+          <a:fontRef idx="minor">
+            <a:schemeClr val="lt1"/>
+          </a:fontRef>
+        </p:style>
+        <p:txBody>
+          <a:bodyPr rtlCol="0" anchor="ctr"/>
+          <a:lstStyle/>
+          <a:p>
+            <a:pPr algn="ctr"/>
+            <a:endParaRPr lang="pt-BR"/>
+          </a:p>
+        </p:txBody>
+      </p:sp>
     </p:spTree>
     <p:extLst>
       <p:ext uri="{BB962C8B-B14F-4D97-AF65-F5344CB8AC3E}">
@@ -31884,8 +31043,8 @@
         </p:nvSpPr>
         <p:spPr>
           <a:xfrm>
-            <a:off x="801511" y="1485097"/>
-            <a:ext cx="7231199" cy="5372903"/>
+            <a:off x="801511" y="1604345"/>
+            <a:ext cx="7231199" cy="5253655"/>
           </a:xfrm>
         </p:spPr>
         <p:txBody>
@@ -31949,23 +31108,7 @@
           <a:p>
             <a:r>
               <a:rPr lang="pt-BR" sz="2400" dirty="0"/>
-              <a:t>O último caso (</a:t>
-            </a:r>
-            <a:r>
-              <a:rPr lang="pt-BR" dirty="0"/>
-              <a:t>default</a:t>
-            </a:r>
-            <a:r>
-              <a:rPr lang="pt-BR" sz="2400" dirty="0"/>
-              <a:t>) não precisa de </a:t>
-            </a:r>
-            <a:r>
-              <a:rPr lang="pt-BR" dirty="0"/>
-              <a:t>break</a:t>
-            </a:r>
-            <a:r>
-              <a:rPr lang="pt-BR" sz="2400" dirty="0"/>
-              <a:t>, por estar no fim.</a:t>
+              <a:t>O último caso (default) não precisa de break, por estar no fim.</a:t>
             </a:r>
           </a:p>
           <a:p>
@@ -32037,329 +31180,6 @@
         <p:cNvPr id="1" name="">
           <a:extLst>
             <a:ext uri="{FF2B5EF4-FFF2-40B4-BE49-F238E27FC236}">
-              <a16:creationId xmlns:a16="http://schemas.microsoft.com/office/drawing/2014/main" id="{A80B7AEB-EDE0-14B5-6D7C-1E53C895889E}"/>
-            </a:ext>
-          </a:extLst>
-        </p:cNvPr>
-        <p:cNvGrpSpPr/>
-        <p:nvPr/>
-      </p:nvGrpSpPr>
-      <p:grpSpPr>
-        <a:xfrm>
-          <a:off x="0" y="0"/>
-          <a:ext cx="0" cy="0"/>
-          <a:chOff x="0" y="0"/>
-          <a:chExt cx="0" cy="0"/>
-        </a:xfrm>
-      </p:grpSpPr>
-      <p:sp>
-        <p:nvSpPr>
-          <p:cNvPr id="5" name="Retângulo 4">
-            <a:extLst>
-              <a:ext uri="{FF2B5EF4-FFF2-40B4-BE49-F238E27FC236}">
-                <a16:creationId xmlns:a16="http://schemas.microsoft.com/office/drawing/2014/main" id="{EB785B21-6AE2-843E-7582-FCB1F8BFBC14}"/>
-              </a:ext>
-            </a:extLst>
-          </p:cNvPr>
-          <p:cNvSpPr/>
-          <p:nvPr/>
-        </p:nvSpPr>
-        <p:spPr>
-          <a:xfrm>
-            <a:off x="0" y="-2"/>
-            <a:ext cx="12192000" cy="1325563"/>
-          </a:xfrm>
-          <a:prstGeom prst="rect">
-            <a:avLst/>
-          </a:prstGeom>
-          <a:solidFill>
-            <a:srgbClr val="418AB3"/>
-          </a:solidFill>
-          <a:ln>
-            <a:solidFill>
-              <a:srgbClr val="418AB3"/>
-            </a:solidFill>
-          </a:ln>
-        </p:spPr>
-        <p:style>
-          <a:lnRef idx="2">
-            <a:schemeClr val="accent1">
-              <a:shade val="15000"/>
-            </a:schemeClr>
-          </a:lnRef>
-          <a:fillRef idx="1">
-            <a:schemeClr val="accent1"/>
-          </a:fillRef>
-          <a:effectRef idx="0">
-            <a:schemeClr val="accent1"/>
-          </a:effectRef>
-          <a:fontRef idx="minor">
-            <a:schemeClr val="lt1"/>
-          </a:fontRef>
-        </p:style>
-        <p:txBody>
-          <a:bodyPr rtlCol="0" anchor="ctr"/>
-          <a:lstStyle/>
-          <a:p>
-            <a:pPr algn="ctr"/>
-            <a:endParaRPr lang="pt-BR" dirty="0"/>
-          </a:p>
-        </p:txBody>
-      </p:sp>
-      <p:sp>
-        <p:nvSpPr>
-          <p:cNvPr id="2" name="Título 1">
-            <a:extLst>
-              <a:ext uri="{FF2B5EF4-FFF2-40B4-BE49-F238E27FC236}">
-                <a16:creationId xmlns:a16="http://schemas.microsoft.com/office/drawing/2014/main" id="{1380F59F-E4B7-1572-CCB8-190C32788A02}"/>
-              </a:ext>
-            </a:extLst>
-          </p:cNvPr>
-          <p:cNvSpPr>
-            <a:spLocks noGrp="1"/>
-          </p:cNvSpPr>
-          <p:nvPr>
-            <p:ph type="title"/>
-          </p:nvPr>
-        </p:nvSpPr>
-        <p:spPr>
-          <a:xfrm>
-            <a:off x="0" y="-1"/>
-            <a:ext cx="12192000" cy="1325563"/>
-          </a:xfrm>
-        </p:spPr>
-        <p:txBody>
-          <a:bodyPr/>
-          <a:lstStyle/>
-          <a:p>
-            <a:pPr algn="ctr"/>
-            <a:r>
-              <a:rPr lang="pt-BR" dirty="0">
-                <a:solidFill>
-                  <a:schemeClr val="bg1"/>
-                </a:solidFill>
-              </a:rPr>
-              <a:t>Comando SWITCH-CASE</a:t>
-            </a:r>
-          </a:p>
-        </p:txBody>
-      </p:sp>
-      <p:sp>
-        <p:nvSpPr>
-          <p:cNvPr id="12" name="AutoShape 6" descr="Lógica Proposicional x Lógica de Argumento ⋆ Colaborae">
-            <a:extLst>
-              <a:ext uri="{FF2B5EF4-FFF2-40B4-BE49-F238E27FC236}">
-                <a16:creationId xmlns:a16="http://schemas.microsoft.com/office/drawing/2014/main" id="{D39FCB66-3350-FACF-C41D-200D43204E7F}"/>
-              </a:ext>
-            </a:extLst>
-          </p:cNvPr>
-          <p:cNvSpPr>
-            <a:spLocks noChangeAspect="1" noChangeArrowheads="1"/>
-          </p:cNvSpPr>
-          <p:nvPr/>
-        </p:nvSpPr>
-        <p:spPr bwMode="auto">
-          <a:xfrm>
-            <a:off x="5943600" y="-1707776"/>
-            <a:ext cx="5289176" cy="5289176"/>
-          </a:xfrm>
-          <a:prstGeom prst="rect">
-            <a:avLst/>
-          </a:prstGeom>
-          <a:noFill/>
-          <a:extLst>
-            <a:ext uri="{909E8E84-426E-40DD-AFC4-6F175D3DCCD1}">
-              <a14:hiddenFill xmlns:a14="http://schemas.microsoft.com/office/drawing/2010/main">
-                <a:solidFill>
-                  <a:srgbClr val="FFFFFF"/>
-                </a:solidFill>
-              </a14:hiddenFill>
-            </a:ext>
-          </a:extLst>
-        </p:spPr>
-        <p:txBody>
-          <a:bodyPr vert="horz" wrap="square" lIns="91440" tIns="45720" rIns="91440" bIns="45720" numCol="1" anchor="t" anchorCtr="0" compatLnSpc="1">
-            <a:prstTxWarp prst="textNoShape">
-              <a:avLst/>
-            </a:prstTxWarp>
-          </a:bodyPr>
-          <a:lstStyle/>
-          <a:p>
-            <a:endParaRPr lang="pt-BR"/>
-          </a:p>
-        </p:txBody>
-      </p:sp>
-      <p:sp>
-        <p:nvSpPr>
-          <p:cNvPr id="6" name="Espaço Reservado para Conteúdo 5">
-            <a:extLst>
-              <a:ext uri="{FF2B5EF4-FFF2-40B4-BE49-F238E27FC236}">
-                <a16:creationId xmlns:a16="http://schemas.microsoft.com/office/drawing/2014/main" id="{8DF14A40-D756-3911-7BE4-A0FCDA8299A8}"/>
-              </a:ext>
-            </a:extLst>
-          </p:cNvPr>
-          <p:cNvSpPr>
-            <a:spLocks noGrp="1"/>
-          </p:cNvSpPr>
-          <p:nvPr>
-            <p:ph idx="1"/>
-          </p:nvPr>
-        </p:nvSpPr>
-        <p:spPr>
-          <a:xfrm>
-            <a:off x="801511" y="1485097"/>
-            <a:ext cx="7231199" cy="5372903"/>
-          </a:xfrm>
-        </p:spPr>
-        <p:txBody>
-          <a:bodyPr>
-            <a:normAutofit lnSpcReduction="10000"/>
-          </a:bodyPr>
-          <a:lstStyle/>
-          <a:p>
-            <a:r>
-              <a:rPr lang="pt-BR" sz="2400" dirty="0"/>
-              <a:t>Busca simplificar o encadeamento de código do </a:t>
-            </a:r>
-            <a:r>
-              <a:rPr lang="pt-BR" sz="2400" b="1" i="1" dirty="0" err="1"/>
-              <a:t>if-else</a:t>
-            </a:r>
-            <a:endParaRPr lang="pt-BR" sz="2400" b="1" i="1" dirty="0"/>
-          </a:p>
-          <a:p>
-            <a:endParaRPr lang="pt-BR" sz="2400" dirty="0"/>
-          </a:p>
-          <a:p>
-            <a:r>
-              <a:rPr lang="pt-BR" sz="2400" dirty="0"/>
-              <a:t>Testa o valor de uma variável e o compara com constantes inteiras ou caracteres em vários blocos</a:t>
-            </a:r>
-          </a:p>
-          <a:p>
-            <a:endParaRPr lang="pt-BR" sz="2400" dirty="0"/>
-          </a:p>
-          <a:p>
-            <a:r>
-              <a:rPr lang="pt-BR" sz="2400" dirty="0"/>
-              <a:t>Se nenhum dos casos for satisfeito, o bloco </a:t>
-            </a:r>
-            <a:r>
-              <a:rPr lang="pt-BR" sz="2400" b="1" i="1" dirty="0"/>
-              <a:t>default</a:t>
-            </a:r>
-            <a:r>
-              <a:rPr lang="pt-BR" sz="2400" dirty="0"/>
-              <a:t> é executado</a:t>
-            </a:r>
-          </a:p>
-          <a:p>
-            <a:endParaRPr lang="pt-BR" sz="2400" b="1" i="1" dirty="0"/>
-          </a:p>
-          <a:p>
-            <a:r>
-              <a:rPr lang="pt-BR" sz="2400" b="1" i="1" dirty="0"/>
-              <a:t>Break</a:t>
-            </a:r>
-            <a:r>
-              <a:rPr lang="pt-BR" sz="2400" dirty="0"/>
-              <a:t> sai imediatamente do switch, continuando a execução do código</a:t>
-            </a:r>
-          </a:p>
-          <a:p>
-            <a:endParaRPr lang="pt-BR" sz="2400" dirty="0"/>
-          </a:p>
-          <a:p>
-            <a:r>
-              <a:rPr lang="pt-BR" sz="2400" dirty="0"/>
-              <a:t>O último caso (</a:t>
-            </a:r>
-            <a:r>
-              <a:rPr lang="pt-BR" dirty="0"/>
-              <a:t>default</a:t>
-            </a:r>
-            <a:r>
-              <a:rPr lang="pt-BR" sz="2400" dirty="0"/>
-              <a:t>) não precisa de </a:t>
-            </a:r>
-            <a:r>
-              <a:rPr lang="pt-BR" dirty="0"/>
-              <a:t>break</a:t>
-            </a:r>
-            <a:r>
-              <a:rPr lang="pt-BR" sz="2400" dirty="0"/>
-              <a:t>, por estar no fim.</a:t>
-            </a:r>
-          </a:p>
-          <a:p>
-            <a:pPr lvl="1"/>
-            <a:endParaRPr lang="pt-BR" sz="2000" b="1" i="1" dirty="0"/>
-          </a:p>
-          <a:p>
-            <a:pPr lvl="1"/>
-            <a:endParaRPr lang="pt-BR" sz="2000" b="1" i="1" dirty="0"/>
-          </a:p>
-          <a:p>
-            <a:pPr lvl="1"/>
-            <a:endParaRPr lang="pt-BR" sz="1800" b="1" i="1" dirty="0"/>
-          </a:p>
-          <a:p>
-            <a:pPr lvl="1"/>
-            <a:endParaRPr lang="pt-BR" sz="1800" b="1" i="1" dirty="0"/>
-          </a:p>
-        </p:txBody>
-      </p:sp>
-      <p:pic>
-        <p:nvPicPr>
-          <p:cNvPr id="7" name="Imagem 6">
-            <a:extLst>
-              <a:ext uri="{FF2B5EF4-FFF2-40B4-BE49-F238E27FC236}">
-                <a16:creationId xmlns:a16="http://schemas.microsoft.com/office/drawing/2014/main" id="{E699A2BD-DF95-A007-4C6C-BCB201AF0FD3}"/>
-              </a:ext>
-            </a:extLst>
-          </p:cNvPr>
-          <p:cNvPicPr>
-            <a:picLocks noChangeAspect="1"/>
-          </p:cNvPicPr>
-          <p:nvPr/>
-        </p:nvPicPr>
-        <p:blipFill>
-          <a:blip r:embed="rId3"/>
-          <a:stretch>
-            <a:fillRect/>
-          </a:stretch>
-        </p:blipFill>
-        <p:spPr>
-          <a:xfrm>
-            <a:off x="8128000" y="1485097"/>
-            <a:ext cx="3949700" cy="5253655"/>
-          </a:xfrm>
-          <a:prstGeom prst="rect">
-            <a:avLst/>
-          </a:prstGeom>
-        </p:spPr>
-      </p:pic>
-    </p:spTree>
-    <p:extLst>
-      <p:ext uri="{BB962C8B-B14F-4D97-AF65-F5344CB8AC3E}">
-        <p14:creationId xmlns:p14="http://schemas.microsoft.com/office/powerpoint/2010/main" val="2210190723"/>
-      </p:ext>
-    </p:extLst>
-  </p:cSld>
-  <p:clrMapOvr>
-    <a:masterClrMapping/>
-  </p:clrMapOvr>
-</p:sld>
-</file>
-
-<file path=ppt/slides/slide47.xml><?xml version="1.0" encoding="utf-8"?>
-<p:sld xmlns:a="http://schemas.openxmlformats.org/drawingml/2006/main" xmlns:r="http://schemas.openxmlformats.org/officeDocument/2006/relationships" xmlns:p="http://schemas.openxmlformats.org/presentationml/2006/main">
-  <p:cSld>
-    <p:spTree>
-      <p:nvGrpSpPr>
-        <p:cNvPr id="1" name="">
-          <a:extLst>
-            <a:ext uri="{FF2B5EF4-FFF2-40B4-BE49-F238E27FC236}">
               <a16:creationId xmlns:a16="http://schemas.microsoft.com/office/drawing/2014/main" id="{27509A80-CA2B-7F6F-AA59-054735CDAE1A}"/>
             </a:ext>
           </a:extLst>
@@ -32510,7 +31330,7 @@
 </p:sld>
 </file>
 
-<file path=ppt/slides/slide48.xml><?xml version="1.0" encoding="utf-8"?>
+<file path=ppt/slides/slide47.xml><?xml version="1.0" encoding="utf-8"?>
 <p:sld xmlns:a="http://schemas.openxmlformats.org/drawingml/2006/main" xmlns:r="http://schemas.openxmlformats.org/officeDocument/2006/relationships" xmlns:p="http://schemas.openxmlformats.org/presentationml/2006/main">
   <p:cSld>
     <p:spTree>
@@ -32859,7 +31679,7 @@
 </p:sld>
 </file>
 
-<file path=ppt/slides/slide49.xml><?xml version="1.0" encoding="utf-8"?>
+<file path=ppt/slides/slide48.xml><?xml version="1.0" encoding="utf-8"?>
 <p:sld xmlns:a="http://schemas.openxmlformats.org/drawingml/2006/main" xmlns:r="http://schemas.openxmlformats.org/officeDocument/2006/relationships" xmlns:p="http://schemas.openxmlformats.org/presentationml/2006/main">
   <p:cSld>
     <p:spTree>
@@ -33144,7 +31964,7 @@
 </p:sld>
 </file>
 
-<file path=ppt/slides/slide5.xml><?xml version="1.0" encoding="utf-8"?>
+<file path=ppt/slides/slide49.xml><?xml version="1.0" encoding="utf-8"?>
 <p:sld xmlns:a="http://schemas.openxmlformats.org/drawingml/2006/main" xmlns:r="http://schemas.openxmlformats.org/officeDocument/2006/relationships" xmlns:p="http://schemas.openxmlformats.org/presentationml/2006/main">
   <p:cSld>
     <p:spTree>
@@ -33152,7 +31972,7 @@
         <p:cNvPr id="1" name="">
           <a:extLst>
             <a:ext uri="{FF2B5EF4-FFF2-40B4-BE49-F238E27FC236}">
-              <a16:creationId xmlns:a16="http://schemas.microsoft.com/office/drawing/2014/main" id="{699BD736-CEF0-B6C0-28BC-774DA5F6E1A8}"/>
+              <a16:creationId xmlns:a16="http://schemas.microsoft.com/office/drawing/2014/main" id="{AB9EDBBA-07AE-8BFE-2904-06A5F1293D39}"/>
             </a:ext>
           </a:extLst>
         </p:cNvPr>
@@ -33172,7 +31992,7 @@
           <p:cNvPr id="5" name="Retângulo 4">
             <a:extLst>
               <a:ext uri="{FF2B5EF4-FFF2-40B4-BE49-F238E27FC236}">
-                <a16:creationId xmlns:a16="http://schemas.microsoft.com/office/drawing/2014/main" id="{717F9DE4-EB99-5874-7C93-C50756B60B56}"/>
+                <a16:creationId xmlns:a16="http://schemas.microsoft.com/office/drawing/2014/main" id="{E293AA67-D501-B974-E7A4-44370381B42A}"/>
               </a:ext>
             </a:extLst>
           </p:cNvPr>
@@ -33226,7 +32046,7 @@
           <p:cNvPr id="2" name="Título 1">
             <a:extLst>
               <a:ext uri="{FF2B5EF4-FFF2-40B4-BE49-F238E27FC236}">
-                <a16:creationId xmlns:a16="http://schemas.microsoft.com/office/drawing/2014/main" id="{BECB663B-29B6-EF3E-539D-7287CF4F6231}"/>
+                <a16:creationId xmlns:a16="http://schemas.microsoft.com/office/drawing/2014/main" id="{3F0C48E0-F262-48BF-558F-3ED89BA7AE89}"/>
               </a:ext>
             </a:extLst>
           </p:cNvPr>
@@ -33254,7 +32074,7 @@
                   <a:schemeClr val="bg1"/>
                 </a:solidFill>
               </a:rPr>
-              <a:t>Linguagem de Máquina</a:t>
+              <a:t>Comando WHILE</a:t>
             </a:r>
           </a:p>
         </p:txBody>
@@ -33264,7 +32084,7 @@
           <p:cNvPr id="12" name="AutoShape 6" descr="Lógica Proposicional x Lógica de Argumento ⋆ Colaborae">
             <a:extLst>
               <a:ext uri="{FF2B5EF4-FFF2-40B4-BE49-F238E27FC236}">
-                <a16:creationId xmlns:a16="http://schemas.microsoft.com/office/drawing/2014/main" id="{3965B379-0BB9-05F4-129D-B28D07BD1ACC}"/>
+                <a16:creationId xmlns:a16="http://schemas.microsoft.com/office/drawing/2014/main" id="{1E6388B1-C1B6-CC28-0FA4-B95A7161F3E2}"/>
               </a:ext>
             </a:extLst>
           </p:cNvPr>
@@ -33309,7 +32129,7 @@
           <p:cNvPr id="6" name="Espaço Reservado para Conteúdo 5">
             <a:extLst>
               <a:ext uri="{FF2B5EF4-FFF2-40B4-BE49-F238E27FC236}">
-                <a16:creationId xmlns:a16="http://schemas.microsoft.com/office/drawing/2014/main" id="{B400FDEC-E1C9-8037-38E3-62ED4ADC7A3F}"/>
+                <a16:creationId xmlns:a16="http://schemas.microsoft.com/office/drawing/2014/main" id="{1372D191-1AF4-F81B-5994-393CCCC35E4E}"/>
               </a:ext>
             </a:extLst>
           </p:cNvPr>
@@ -33322,8 +32142,8 @@
         </p:nvSpPr>
         <p:spPr>
           <a:xfrm>
-            <a:off x="742377" y="1640958"/>
-            <a:ext cx="5527874" cy="4887691"/>
+            <a:off x="3693280" y="1623210"/>
+            <a:ext cx="4811335" cy="550861"/>
           </a:xfrm>
         </p:spPr>
         <p:txBody>
@@ -33334,191 +32154,57 @@
           <a:p>
             <a:r>
               <a:rPr lang="pt-BR" sz="2400" dirty="0"/>
-              <a:t>Forma básica de instrução compreendida pelo computador</a:t>
-            </a:r>
-            <a:endParaRPr lang="pt-BR" sz="2000" dirty="0"/>
-          </a:p>
-          <a:p>
-            <a:pPr marL="0" indent="0">
-              <a:buNone/>
-            </a:pPr>
-            <a:endParaRPr lang="pt-BR" sz="2000" dirty="0"/>
-          </a:p>
-          <a:p>
-            <a:r>
-              <a:rPr lang="pt-BR" sz="2400" dirty="0"/>
-              <a:t>Caracterizada por ser uma sequências de 0 e 1, ou de valores Hexadecimais </a:t>
-            </a:r>
-          </a:p>
-          <a:p>
-            <a:endParaRPr lang="pt-BR" sz="2400" dirty="0"/>
-          </a:p>
-          <a:p>
-            <a:r>
-              <a:rPr lang="pt-BR" sz="2400" dirty="0"/>
-              <a:t>Cada arquitetura compreende sua própria linguagem de máquina</a:t>
-            </a:r>
-          </a:p>
-          <a:p>
-            <a:endParaRPr lang="pt-BR" sz="2400" dirty="0"/>
-          </a:p>
-          <a:p>
-            <a:r>
-              <a:rPr lang="pt-BR" sz="2400" dirty="0"/>
-              <a:t>Opera de acordo com o projeto de Hardware do processador</a:t>
-            </a:r>
-            <a:endParaRPr lang="pt-BR" dirty="0"/>
-          </a:p>
-          <a:p>
-            <a:endParaRPr lang="pt-BR" sz="2400" dirty="0"/>
+              <a:t>Exemplo e sintaxe:</a:t>
+            </a:r>
+          </a:p>
+          <a:p>
+            <a:pPr lvl="1"/>
+            <a:endParaRPr lang="pt-BR" sz="2000" b="1" i="1" dirty="0"/>
+          </a:p>
+          <a:p>
+            <a:pPr lvl="1"/>
+            <a:endParaRPr lang="pt-BR" sz="1800" b="1" i="1" dirty="0"/>
+          </a:p>
+          <a:p>
+            <a:pPr lvl="1"/>
+            <a:endParaRPr lang="pt-BR" sz="1800" b="1" i="1" dirty="0"/>
           </a:p>
         </p:txBody>
       </p:sp>
       <p:pic>
         <p:nvPicPr>
-          <p:cNvPr id="4098" name="Picture 2" descr="Importância da linguem de Programação de Baixo Nível">
-            <a:extLst>
-              <a:ext uri="{FF2B5EF4-FFF2-40B4-BE49-F238E27FC236}">
-                <a16:creationId xmlns:a16="http://schemas.microsoft.com/office/drawing/2014/main" id="{36D343F2-A8DE-A76F-F763-075091475246}"/>
+          <p:cNvPr id="9" name="Imagem 8">
+            <a:extLst>
+              <a:ext uri="{FF2B5EF4-FFF2-40B4-BE49-F238E27FC236}">
+                <a16:creationId xmlns:a16="http://schemas.microsoft.com/office/drawing/2014/main" id="{26337D16-C5EE-224A-CEFC-AD63B69C4E12}"/>
               </a:ext>
             </a:extLst>
           </p:cNvPr>
           <p:cNvPicPr>
-            <a:picLocks noChangeAspect="1" noChangeArrowheads="1"/>
+            <a:picLocks noChangeAspect="1"/>
           </p:cNvPicPr>
           <p:nvPr/>
         </p:nvPicPr>
-        <p:blipFill rotWithShape="1">
-          <a:blip r:embed="rId3">
-            <a:extLst>
-              <a:ext uri="{28A0092B-C50C-407E-A947-70E740481C1C}">
-                <a14:useLocalDpi xmlns:a14="http://schemas.microsoft.com/office/drawing/2010/main" val="0"/>
-              </a:ext>
-            </a:extLst>
-          </a:blip>
-          <a:srcRect l="40928" r="1050" b="68373"/>
+        <p:blipFill>
+          <a:blip r:embed="rId3"/>
           <a:stretch>
             <a:fillRect/>
           </a:stretch>
         </p:blipFill>
-        <p:spPr bwMode="auto">
+        <p:spPr>
           <a:xfrm>
-            <a:off x="7909790" y="1814843"/>
-            <a:ext cx="3067291" cy="1277273"/>
+            <a:off x="3703224" y="2174071"/>
+            <a:ext cx="4817231" cy="4700802"/>
           </a:xfrm>
           <a:prstGeom prst="rect">
             <a:avLst/>
           </a:prstGeom>
-          <a:noFill/>
-          <a:extLst>
-            <a:ext uri="{909E8E84-426E-40DD-AFC4-6F175D3DCCD1}">
-              <a14:hiddenFill xmlns:a14="http://schemas.microsoft.com/office/drawing/2010/main">
-                <a:solidFill>
-                  <a:srgbClr val="FFFFFF"/>
-                </a:solidFill>
-              </a14:hiddenFill>
-            </a:ext>
-          </a:extLst>
         </p:spPr>
       </p:pic>
-      <p:pic>
-        <p:nvPicPr>
-          <p:cNvPr id="4100" name="Picture 4" descr="Organization of Computer Systems: ISA, Machine Language, Number Systems">
-            <a:extLst>
-              <a:ext uri="{FF2B5EF4-FFF2-40B4-BE49-F238E27FC236}">
-                <a16:creationId xmlns:a16="http://schemas.microsoft.com/office/drawing/2014/main" id="{103232D8-49E8-B066-4C6A-8F3AF74E3720}"/>
-              </a:ext>
-            </a:extLst>
-          </p:cNvPr>
-          <p:cNvPicPr>
-            <a:picLocks noChangeAspect="1" noChangeArrowheads="1"/>
-          </p:cNvPicPr>
-          <p:nvPr/>
-        </p:nvPicPr>
-        <p:blipFill>
-          <a:blip r:embed="rId4">
-            <a:extLst>
-              <a:ext uri="{28A0092B-C50C-407E-A947-70E740481C1C}">
-                <a14:useLocalDpi xmlns:a14="http://schemas.microsoft.com/office/drawing/2010/main" val="0"/>
-              </a:ext>
-            </a:extLst>
-          </a:blip>
-          <a:srcRect/>
-          <a:stretch>
-            <a:fillRect/>
-          </a:stretch>
-        </p:blipFill>
-        <p:spPr bwMode="auto">
-          <a:xfrm>
-            <a:off x="6749863" y="3339436"/>
-            <a:ext cx="4962525" cy="3028950"/>
-          </a:xfrm>
-          <a:prstGeom prst="rect">
-            <a:avLst/>
-          </a:prstGeom>
-          <a:noFill/>
-          <a:extLst>
-            <a:ext uri="{909E8E84-426E-40DD-AFC4-6F175D3DCCD1}">
-              <a14:hiddenFill xmlns:a14="http://schemas.microsoft.com/office/drawing/2010/main">
-                <a:solidFill>
-                  <a:srgbClr val="FFFFFF"/>
-                </a:solidFill>
-              </a14:hiddenFill>
-            </a:ext>
-          </a:extLst>
-        </p:spPr>
-      </p:pic>
-      <p:sp>
-        <p:nvSpPr>
-          <p:cNvPr id="4" name="CaixaDeTexto 3">
-            <a:extLst>
-              <a:ext uri="{FF2B5EF4-FFF2-40B4-BE49-F238E27FC236}">
-                <a16:creationId xmlns:a16="http://schemas.microsoft.com/office/drawing/2014/main" id="{3B9E8019-D6C5-3D11-235D-94FE651B5926}"/>
-              </a:ext>
-            </a:extLst>
-          </p:cNvPr>
-          <p:cNvSpPr txBox="1"/>
-          <p:nvPr/>
-        </p:nvSpPr>
-        <p:spPr>
-          <a:xfrm>
-            <a:off x="7498054" y="6343983"/>
-            <a:ext cx="3466142" cy="369332"/>
-          </a:xfrm>
-          <a:prstGeom prst="rect">
-            <a:avLst/>
-          </a:prstGeom>
-          <a:noFill/>
-        </p:spPr>
-        <p:txBody>
-          <a:bodyPr wrap="none" rtlCol="0">
-            <a:spAutoFit/>
-          </a:bodyPr>
-          <a:lstStyle/>
-          <a:p>
-            <a:r>
-              <a:rPr lang="pt-BR" dirty="0" err="1"/>
-              <a:t>Instruction</a:t>
-            </a:r>
-            <a:r>
-              <a:rPr lang="pt-BR" dirty="0"/>
-              <a:t> Set </a:t>
-            </a:r>
-            <a:r>
-              <a:rPr lang="pt-BR" dirty="0" err="1"/>
-              <a:t>Architecture</a:t>
-            </a:r>
-            <a:r>
-              <a:rPr lang="pt-BR" dirty="0"/>
-              <a:t> – MIPS</a:t>
-            </a:r>
-          </a:p>
-        </p:txBody>
-      </p:sp>
     </p:spTree>
     <p:extLst>
       <p:ext uri="{BB962C8B-B14F-4D97-AF65-F5344CB8AC3E}">
-        <p14:creationId xmlns:p14="http://schemas.microsoft.com/office/powerpoint/2010/main" val="4102101521"/>
+        <p14:creationId xmlns:p14="http://schemas.microsoft.com/office/powerpoint/2010/main" val="3799537098"/>
       </p:ext>
     </p:extLst>
   </p:cSld>
@@ -33528,7 +32214,7 @@
 </p:sld>
 </file>
 
-<file path=ppt/slides/slide50.xml><?xml version="1.0" encoding="utf-8"?>
+<file path=ppt/slides/slide5.xml><?xml version="1.0" encoding="utf-8"?>
 <p:sld xmlns:a="http://schemas.openxmlformats.org/drawingml/2006/main" xmlns:r="http://schemas.openxmlformats.org/officeDocument/2006/relationships" xmlns:p="http://schemas.openxmlformats.org/presentationml/2006/main">
   <p:cSld>
     <p:spTree>
@@ -33536,7 +32222,7 @@
         <p:cNvPr id="1" name="">
           <a:extLst>
             <a:ext uri="{FF2B5EF4-FFF2-40B4-BE49-F238E27FC236}">
-              <a16:creationId xmlns:a16="http://schemas.microsoft.com/office/drawing/2014/main" id="{AB9EDBBA-07AE-8BFE-2904-06A5F1293D39}"/>
+              <a16:creationId xmlns:a16="http://schemas.microsoft.com/office/drawing/2014/main" id="{699BD736-CEF0-B6C0-28BC-774DA5F6E1A8}"/>
             </a:ext>
           </a:extLst>
         </p:cNvPr>
@@ -33556,7 +32242,7 @@
           <p:cNvPr id="5" name="Retângulo 4">
             <a:extLst>
               <a:ext uri="{FF2B5EF4-FFF2-40B4-BE49-F238E27FC236}">
-                <a16:creationId xmlns:a16="http://schemas.microsoft.com/office/drawing/2014/main" id="{E293AA67-D501-B974-E7A4-44370381B42A}"/>
+                <a16:creationId xmlns:a16="http://schemas.microsoft.com/office/drawing/2014/main" id="{717F9DE4-EB99-5874-7C93-C50756B60B56}"/>
               </a:ext>
             </a:extLst>
           </p:cNvPr>
@@ -33610,7 +32296,7 @@
           <p:cNvPr id="2" name="Título 1">
             <a:extLst>
               <a:ext uri="{FF2B5EF4-FFF2-40B4-BE49-F238E27FC236}">
-                <a16:creationId xmlns:a16="http://schemas.microsoft.com/office/drawing/2014/main" id="{3F0C48E0-F262-48BF-558F-3ED89BA7AE89}"/>
+                <a16:creationId xmlns:a16="http://schemas.microsoft.com/office/drawing/2014/main" id="{BECB663B-29B6-EF3E-539D-7287CF4F6231}"/>
               </a:ext>
             </a:extLst>
           </p:cNvPr>
@@ -33638,7 +32324,7 @@
                   <a:schemeClr val="bg1"/>
                 </a:solidFill>
               </a:rPr>
-              <a:t>Comando WHILE</a:t>
+              <a:t>Linguagem de Máquina</a:t>
             </a:r>
           </a:p>
         </p:txBody>
@@ -33648,7 +32334,7 @@
           <p:cNvPr id="12" name="AutoShape 6" descr="Lógica Proposicional x Lógica de Argumento ⋆ Colaborae">
             <a:extLst>
               <a:ext uri="{FF2B5EF4-FFF2-40B4-BE49-F238E27FC236}">
-                <a16:creationId xmlns:a16="http://schemas.microsoft.com/office/drawing/2014/main" id="{1E6388B1-C1B6-CC28-0FA4-B95A7161F3E2}"/>
+                <a16:creationId xmlns:a16="http://schemas.microsoft.com/office/drawing/2014/main" id="{3965B379-0BB9-05F4-129D-B28D07BD1ACC}"/>
               </a:ext>
             </a:extLst>
           </p:cNvPr>
@@ -33693,7 +32379,7 @@
           <p:cNvPr id="6" name="Espaço Reservado para Conteúdo 5">
             <a:extLst>
               <a:ext uri="{FF2B5EF4-FFF2-40B4-BE49-F238E27FC236}">
-                <a16:creationId xmlns:a16="http://schemas.microsoft.com/office/drawing/2014/main" id="{1372D191-1AF4-F81B-5994-393CCCC35E4E}"/>
+                <a16:creationId xmlns:a16="http://schemas.microsoft.com/office/drawing/2014/main" id="{B400FDEC-E1C9-8037-38E3-62ED4ADC7A3F}"/>
               </a:ext>
             </a:extLst>
           </p:cNvPr>
@@ -33706,8 +32392,8 @@
         </p:nvSpPr>
         <p:spPr>
           <a:xfrm>
-            <a:off x="3693280" y="1623210"/>
-            <a:ext cx="4811335" cy="550861"/>
+            <a:off x="742377" y="1640958"/>
+            <a:ext cx="5527874" cy="4887691"/>
           </a:xfrm>
         </p:spPr>
         <p:txBody>
@@ -33718,57 +32404,191 @@
           <a:p>
             <a:r>
               <a:rPr lang="pt-BR" sz="2400" dirty="0"/>
-              <a:t>Exemplo e sintaxe:</a:t>
-            </a:r>
-          </a:p>
-          <a:p>
-            <a:pPr lvl="1"/>
-            <a:endParaRPr lang="pt-BR" sz="2000" b="1" i="1" dirty="0"/>
-          </a:p>
-          <a:p>
-            <a:pPr lvl="1"/>
-            <a:endParaRPr lang="pt-BR" sz="1800" b="1" i="1" dirty="0"/>
-          </a:p>
-          <a:p>
-            <a:pPr lvl="1"/>
-            <a:endParaRPr lang="pt-BR" sz="1800" b="1" i="1" dirty="0"/>
+              <a:t>Forma básica de instrução compreendida pelo computador</a:t>
+            </a:r>
+            <a:endParaRPr lang="pt-BR" sz="2000" dirty="0"/>
+          </a:p>
+          <a:p>
+            <a:pPr marL="0" indent="0">
+              <a:buNone/>
+            </a:pPr>
+            <a:endParaRPr lang="pt-BR" sz="2000" dirty="0"/>
+          </a:p>
+          <a:p>
+            <a:r>
+              <a:rPr lang="pt-BR" sz="2400" dirty="0"/>
+              <a:t>Caracterizada por ser uma sequências de 0 e 1, ou de valores Hexadecimais </a:t>
+            </a:r>
+          </a:p>
+          <a:p>
+            <a:endParaRPr lang="pt-BR" sz="2400" dirty="0"/>
+          </a:p>
+          <a:p>
+            <a:r>
+              <a:rPr lang="pt-BR" sz="2400" dirty="0"/>
+              <a:t>Cada arquitetura compreende sua própria linguagem de máquina</a:t>
+            </a:r>
+          </a:p>
+          <a:p>
+            <a:endParaRPr lang="pt-BR" sz="2400" dirty="0"/>
+          </a:p>
+          <a:p>
+            <a:r>
+              <a:rPr lang="pt-BR" sz="2400" dirty="0"/>
+              <a:t>Opera de acordo com o projeto de Hardware do processador</a:t>
+            </a:r>
+            <a:endParaRPr lang="pt-BR" dirty="0"/>
+          </a:p>
+          <a:p>
+            <a:endParaRPr lang="pt-BR" sz="2400" dirty="0"/>
           </a:p>
         </p:txBody>
       </p:sp>
       <p:pic>
         <p:nvPicPr>
-          <p:cNvPr id="9" name="Imagem 8">
-            <a:extLst>
-              <a:ext uri="{FF2B5EF4-FFF2-40B4-BE49-F238E27FC236}">
-                <a16:creationId xmlns:a16="http://schemas.microsoft.com/office/drawing/2014/main" id="{26337D16-C5EE-224A-CEFC-AD63B69C4E12}"/>
+          <p:cNvPr id="4098" name="Picture 2" descr="Importância da linguem de Programação de Baixo Nível">
+            <a:extLst>
+              <a:ext uri="{FF2B5EF4-FFF2-40B4-BE49-F238E27FC236}">
+                <a16:creationId xmlns:a16="http://schemas.microsoft.com/office/drawing/2014/main" id="{36D343F2-A8DE-A76F-F763-075091475246}"/>
               </a:ext>
             </a:extLst>
           </p:cNvPr>
           <p:cNvPicPr>
-            <a:picLocks noChangeAspect="1"/>
+            <a:picLocks noChangeAspect="1" noChangeArrowheads="1"/>
+          </p:cNvPicPr>
+          <p:nvPr/>
+        </p:nvPicPr>
+        <p:blipFill rotWithShape="1">
+          <a:blip r:embed="rId3">
+            <a:extLst>
+              <a:ext uri="{28A0092B-C50C-407E-A947-70E740481C1C}">
+                <a14:useLocalDpi xmlns:a14="http://schemas.microsoft.com/office/drawing/2010/main" val="0"/>
+              </a:ext>
+            </a:extLst>
+          </a:blip>
+          <a:srcRect l="40928" r="1050" b="68373"/>
+          <a:stretch>
+            <a:fillRect/>
+          </a:stretch>
+        </p:blipFill>
+        <p:spPr bwMode="auto">
+          <a:xfrm>
+            <a:off x="7909790" y="1814843"/>
+            <a:ext cx="3067291" cy="1277273"/>
+          </a:xfrm>
+          <a:prstGeom prst="rect">
+            <a:avLst/>
+          </a:prstGeom>
+          <a:noFill/>
+          <a:extLst>
+            <a:ext uri="{909E8E84-426E-40DD-AFC4-6F175D3DCCD1}">
+              <a14:hiddenFill xmlns:a14="http://schemas.microsoft.com/office/drawing/2010/main">
+                <a:solidFill>
+                  <a:srgbClr val="FFFFFF"/>
+                </a:solidFill>
+              </a14:hiddenFill>
+            </a:ext>
+          </a:extLst>
+        </p:spPr>
+      </p:pic>
+      <p:pic>
+        <p:nvPicPr>
+          <p:cNvPr id="4100" name="Picture 4" descr="Organization of Computer Systems: ISA, Machine Language, Number Systems">
+            <a:extLst>
+              <a:ext uri="{FF2B5EF4-FFF2-40B4-BE49-F238E27FC236}">
+                <a16:creationId xmlns:a16="http://schemas.microsoft.com/office/drawing/2014/main" id="{103232D8-49E8-B066-4C6A-8F3AF74E3720}"/>
+              </a:ext>
+            </a:extLst>
+          </p:cNvPr>
+          <p:cNvPicPr>
+            <a:picLocks noChangeAspect="1" noChangeArrowheads="1"/>
           </p:cNvPicPr>
           <p:nvPr/>
         </p:nvPicPr>
         <p:blipFill>
-          <a:blip r:embed="rId3"/>
+          <a:blip r:embed="rId4">
+            <a:extLst>
+              <a:ext uri="{28A0092B-C50C-407E-A947-70E740481C1C}">
+                <a14:useLocalDpi xmlns:a14="http://schemas.microsoft.com/office/drawing/2010/main" val="0"/>
+              </a:ext>
+            </a:extLst>
+          </a:blip>
+          <a:srcRect/>
           <a:stretch>
             <a:fillRect/>
           </a:stretch>
         </p:blipFill>
-        <p:spPr>
+        <p:spPr bwMode="auto">
           <a:xfrm>
-            <a:off x="3687384" y="2174072"/>
-            <a:ext cx="4817231" cy="4700802"/>
+            <a:off x="6749863" y="3339436"/>
+            <a:ext cx="4962525" cy="3028950"/>
           </a:xfrm>
           <a:prstGeom prst="rect">
             <a:avLst/>
           </a:prstGeom>
+          <a:noFill/>
+          <a:extLst>
+            <a:ext uri="{909E8E84-426E-40DD-AFC4-6F175D3DCCD1}">
+              <a14:hiddenFill xmlns:a14="http://schemas.microsoft.com/office/drawing/2010/main">
+                <a:solidFill>
+                  <a:srgbClr val="FFFFFF"/>
+                </a:solidFill>
+              </a14:hiddenFill>
+            </a:ext>
+          </a:extLst>
         </p:spPr>
       </p:pic>
+      <p:sp>
+        <p:nvSpPr>
+          <p:cNvPr id="4" name="CaixaDeTexto 3">
+            <a:extLst>
+              <a:ext uri="{FF2B5EF4-FFF2-40B4-BE49-F238E27FC236}">
+                <a16:creationId xmlns:a16="http://schemas.microsoft.com/office/drawing/2014/main" id="{3B9E8019-D6C5-3D11-235D-94FE651B5926}"/>
+              </a:ext>
+            </a:extLst>
+          </p:cNvPr>
+          <p:cNvSpPr txBox="1"/>
+          <p:nvPr/>
+        </p:nvSpPr>
+        <p:spPr>
+          <a:xfrm>
+            <a:off x="7498054" y="6343983"/>
+            <a:ext cx="3466142" cy="369332"/>
+          </a:xfrm>
+          <a:prstGeom prst="rect">
+            <a:avLst/>
+          </a:prstGeom>
+          <a:noFill/>
+        </p:spPr>
+        <p:txBody>
+          <a:bodyPr wrap="none" rtlCol="0">
+            <a:spAutoFit/>
+          </a:bodyPr>
+          <a:lstStyle/>
+          <a:p>
+            <a:r>
+              <a:rPr lang="pt-BR" dirty="0" err="1"/>
+              <a:t>Instruction</a:t>
+            </a:r>
+            <a:r>
+              <a:rPr lang="pt-BR" dirty="0"/>
+              <a:t> Set </a:t>
+            </a:r>
+            <a:r>
+              <a:rPr lang="pt-BR" dirty="0" err="1"/>
+              <a:t>Architecture</a:t>
+            </a:r>
+            <a:r>
+              <a:rPr lang="pt-BR" dirty="0"/>
+              <a:t> – MIPS</a:t>
+            </a:r>
+          </a:p>
+        </p:txBody>
+      </p:sp>
     </p:spTree>
     <p:extLst>
       <p:ext uri="{BB962C8B-B14F-4D97-AF65-F5344CB8AC3E}">
-        <p14:creationId xmlns:p14="http://schemas.microsoft.com/office/powerpoint/2010/main" val="3799537098"/>
+        <p14:creationId xmlns:p14="http://schemas.microsoft.com/office/powerpoint/2010/main" val="4102101521"/>
       </p:ext>
     </p:extLst>
   </p:cSld>
@@ -33778,7 +32598,7 @@
 </p:sld>
 </file>
 
-<file path=ppt/slides/slide51.xml><?xml version="1.0" encoding="utf-8"?>
+<file path=ppt/slides/slide50.xml><?xml version="1.0" encoding="utf-8"?>
 <p:sld xmlns:a="http://schemas.openxmlformats.org/drawingml/2006/main" xmlns:r="http://schemas.openxmlformats.org/officeDocument/2006/relationships" xmlns:p="http://schemas.openxmlformats.org/presentationml/2006/main">
   <p:cSld>
     <p:spTree>
@@ -34073,7 +32893,7 @@
 </p:sld>
 </file>
 
-<file path=ppt/slides/slide52.xml><?xml version="1.0" encoding="utf-8"?>
+<file path=ppt/slides/slide51.xml><?xml version="1.0" encoding="utf-8"?>
 <p:sld xmlns:a="http://schemas.openxmlformats.org/drawingml/2006/main" xmlns:r="http://schemas.openxmlformats.org/officeDocument/2006/relationships" xmlns:p="http://schemas.openxmlformats.org/presentationml/2006/main">
   <p:cSld>
     <p:spTree>
@@ -34323,7 +33143,7 @@
 </p:sld>
 </file>
 
-<file path=ppt/slides/slide53.xml><?xml version="1.0" encoding="utf-8"?>
+<file path=ppt/slides/slide52.xml><?xml version="1.0" encoding="utf-8"?>
 <p:sld xmlns:a="http://schemas.openxmlformats.org/drawingml/2006/main" xmlns:r="http://schemas.openxmlformats.org/officeDocument/2006/relationships" xmlns:p="http://schemas.openxmlformats.org/presentationml/2006/main">
   <p:cSld>
     <p:spTree>
@@ -34654,7 +33474,7 @@
 </p:sld>
 </file>
 
-<file path=ppt/slides/slide54.xml><?xml version="1.0" encoding="utf-8"?>
+<file path=ppt/slides/slide53.xml><?xml version="1.0" encoding="utf-8"?>
 <p:sld xmlns:a="http://schemas.openxmlformats.org/drawingml/2006/main" xmlns:r="http://schemas.openxmlformats.org/officeDocument/2006/relationships" xmlns:p="http://schemas.openxmlformats.org/presentationml/2006/main">
   <p:cSld>
     <p:spTree>
@@ -34883,7 +33703,7 @@
         </p:blipFill>
         <p:spPr>
           <a:xfrm>
-            <a:off x="3451412" y="3122767"/>
+            <a:off x="3451412" y="3160867"/>
             <a:ext cx="5289176" cy="3697133"/>
           </a:xfrm>
           <a:prstGeom prst="rect">

</xml_diff>

<commit_message>
Atualização de aulas MD PT2 17/08
</commit_message>
<xml_diff>
--- a/UNIUBE-LP/Teoria_LP.pptx
+++ b/UNIUBE-LP/Teoria_LP.pptx
@@ -250,7 +250,7 @@
           <a:p>
             <a:fld id="{6ED03497-8374-466E-85FA-95E1138D8F6E}" type="datetimeFigureOut">
               <a:rPr lang="pt-BR" smtClean="0"/>
-              <a:t>13/08/2026</a:t>
+              <a:t>17/08/2026</a:t>
             </a:fld>
             <a:endParaRPr lang="pt-BR"/>
           </a:p>
@@ -11129,7 +11129,7 @@
           <a:p>
             <a:fld id="{A87E3B6E-8316-4A1C-BADA-DB7F3456EEF1}" type="datetimeFigureOut">
               <a:rPr lang="pt-BR" smtClean="0"/>
-              <a:t>13/08/2026</a:t>
+              <a:t>17/08/2026</a:t>
             </a:fld>
             <a:endParaRPr lang="pt-BR"/>
           </a:p>
@@ -11327,7 +11327,7 @@
           <a:p>
             <a:fld id="{A87E3B6E-8316-4A1C-BADA-DB7F3456EEF1}" type="datetimeFigureOut">
               <a:rPr lang="pt-BR" smtClean="0"/>
-              <a:t>13/08/2026</a:t>
+              <a:t>17/08/2026</a:t>
             </a:fld>
             <a:endParaRPr lang="pt-BR"/>
           </a:p>
@@ -11535,7 +11535,7 @@
           <a:p>
             <a:fld id="{A87E3B6E-8316-4A1C-BADA-DB7F3456EEF1}" type="datetimeFigureOut">
               <a:rPr lang="pt-BR" smtClean="0"/>
-              <a:t>13/08/2026</a:t>
+              <a:t>17/08/2026</a:t>
             </a:fld>
             <a:endParaRPr lang="pt-BR"/>
           </a:p>
@@ -11771,7 +11771,7 @@
           <a:p>
             <a:fld id="{A87E3B6E-8316-4A1C-BADA-DB7F3456EEF1}" type="datetimeFigureOut">
               <a:rPr lang="pt-BR" smtClean="0"/>
-              <a:t>13/08/2026</a:t>
+              <a:t>17/08/2026</a:t>
             </a:fld>
             <a:endParaRPr lang="pt-BR"/>
           </a:p>
@@ -11941,7 +11941,7 @@
           <a:p>
             <a:fld id="{A87E3B6E-8316-4A1C-BADA-DB7F3456EEF1}" type="datetimeFigureOut">
               <a:rPr lang="pt-BR" smtClean="0"/>
-              <a:t>13/08/2026</a:t>
+              <a:t>17/08/2026</a:t>
             </a:fld>
             <a:endParaRPr lang="pt-BR"/>
           </a:p>
@@ -12209,7 +12209,7 @@
           <a:p>
             <a:fld id="{A87E3B6E-8316-4A1C-BADA-DB7F3456EEF1}" type="datetimeFigureOut">
               <a:rPr lang="pt-BR" smtClean="0"/>
-              <a:t>13/08/2026</a:t>
+              <a:t>17/08/2026</a:t>
             </a:fld>
             <a:endParaRPr lang="pt-BR"/>
           </a:p>
@@ -12441,7 +12441,7 @@
           <a:p>
             <a:fld id="{A87E3B6E-8316-4A1C-BADA-DB7F3456EEF1}" type="datetimeFigureOut">
               <a:rPr lang="pt-BR" smtClean="0"/>
-              <a:t>13/08/2026</a:t>
+              <a:t>17/08/2026</a:t>
             </a:fld>
             <a:endParaRPr lang="pt-BR"/>
           </a:p>
@@ -12796,7 +12796,7 @@
           <a:p>
             <a:fld id="{A87E3B6E-8316-4A1C-BADA-DB7F3456EEF1}" type="datetimeFigureOut">
               <a:rPr lang="pt-BR" smtClean="0"/>
-              <a:t>13/08/2026</a:t>
+              <a:t>17/08/2026</a:t>
             </a:fld>
             <a:endParaRPr lang="pt-BR"/>
           </a:p>
@@ -12937,7 +12937,7 @@
           <a:p>
             <a:fld id="{A87E3B6E-8316-4A1C-BADA-DB7F3456EEF1}" type="datetimeFigureOut">
               <a:rPr lang="pt-BR" smtClean="0"/>
-              <a:t>13/08/2026</a:t>
+              <a:t>17/08/2026</a:t>
             </a:fld>
             <a:endParaRPr lang="pt-BR"/>
           </a:p>
@@ -13032,7 +13032,7 @@
           <a:p>
             <a:fld id="{A87E3B6E-8316-4A1C-BADA-DB7F3456EEF1}" type="datetimeFigureOut">
               <a:rPr lang="pt-BR" smtClean="0"/>
-              <a:t>13/08/2026</a:t>
+              <a:t>17/08/2026</a:t>
             </a:fld>
             <a:endParaRPr lang="pt-BR"/>
           </a:p>
@@ -13389,7 +13389,7 @@
           <a:p>
             <a:fld id="{A87E3B6E-8316-4A1C-BADA-DB7F3456EEF1}" type="datetimeFigureOut">
               <a:rPr lang="pt-BR" smtClean="0"/>
-              <a:t>13/08/2026</a:t>
+              <a:t>17/08/2026</a:t>
             </a:fld>
             <a:endParaRPr lang="pt-BR"/>
           </a:p>
@@ -13590,7 +13590,7 @@
           <a:p>
             <a:fld id="{A87E3B6E-8316-4A1C-BADA-DB7F3456EEF1}" type="datetimeFigureOut">
               <a:rPr lang="pt-BR" smtClean="0"/>
-              <a:t>13/08/2026</a:t>
+              <a:t>17/08/2026</a:t>
             </a:fld>
             <a:endParaRPr lang="pt-BR"/>
           </a:p>
@@ -13943,7 +13943,7 @@
           <a:p>
             <a:fld id="{A87E3B6E-8316-4A1C-BADA-DB7F3456EEF1}" type="datetimeFigureOut">
               <a:rPr lang="pt-BR" smtClean="0"/>
-              <a:t>13/08/2026</a:t>
+              <a:t>17/08/2026</a:t>
             </a:fld>
             <a:endParaRPr lang="pt-BR"/>
           </a:p>
@@ -14128,7 +14128,7 @@
           <a:p>
             <a:fld id="{A87E3B6E-8316-4A1C-BADA-DB7F3456EEF1}" type="datetimeFigureOut">
               <a:rPr lang="pt-BR" smtClean="0"/>
-              <a:t>13/08/2026</a:t>
+              <a:t>17/08/2026</a:t>
             </a:fld>
             <a:endParaRPr lang="pt-BR"/>
           </a:p>
@@ -14308,7 +14308,7 @@
           <a:p>
             <a:fld id="{A87E3B6E-8316-4A1C-BADA-DB7F3456EEF1}" type="datetimeFigureOut">
               <a:rPr lang="pt-BR" smtClean="0"/>
-              <a:t>13/08/2026</a:t>
+              <a:t>17/08/2026</a:t>
             </a:fld>
             <a:endParaRPr lang="pt-BR"/>
           </a:p>
@@ -14571,7 +14571,7 @@
           <a:p>
             <a:fld id="{A87E3B6E-8316-4A1C-BADA-DB7F3456EEF1}" type="datetimeFigureOut">
               <a:rPr lang="pt-BR" smtClean="0"/>
-              <a:t>13/08/2026</a:t>
+              <a:t>17/08/2026</a:t>
             </a:fld>
             <a:endParaRPr lang="pt-BR"/>
           </a:p>
@@ -14836,7 +14836,7 @@
           <a:p>
             <a:fld id="{A87E3B6E-8316-4A1C-BADA-DB7F3456EEF1}" type="datetimeFigureOut">
               <a:rPr lang="pt-BR" smtClean="0"/>
-              <a:t>13/08/2026</a:t>
+              <a:t>17/08/2026</a:t>
             </a:fld>
             <a:endParaRPr lang="pt-BR"/>
           </a:p>
@@ -15248,7 +15248,7 @@
           <a:p>
             <a:fld id="{A87E3B6E-8316-4A1C-BADA-DB7F3456EEF1}" type="datetimeFigureOut">
               <a:rPr lang="pt-BR" smtClean="0"/>
-              <a:t>13/08/2026</a:t>
+              <a:t>17/08/2026</a:t>
             </a:fld>
             <a:endParaRPr lang="pt-BR"/>
           </a:p>
@@ -15389,7 +15389,7 @@
           <a:p>
             <a:fld id="{A87E3B6E-8316-4A1C-BADA-DB7F3456EEF1}" type="datetimeFigureOut">
               <a:rPr lang="pt-BR" smtClean="0"/>
-              <a:t>13/08/2026</a:t>
+              <a:t>17/08/2026</a:t>
             </a:fld>
             <a:endParaRPr lang="pt-BR"/>
           </a:p>
@@ -15502,7 +15502,7 @@
           <a:p>
             <a:fld id="{A87E3B6E-8316-4A1C-BADA-DB7F3456EEF1}" type="datetimeFigureOut">
               <a:rPr lang="pt-BR" smtClean="0"/>
-              <a:t>13/08/2026</a:t>
+              <a:t>17/08/2026</a:t>
             </a:fld>
             <a:endParaRPr lang="pt-BR"/>
           </a:p>
@@ -15813,7 +15813,7 @@
           <a:p>
             <a:fld id="{A87E3B6E-8316-4A1C-BADA-DB7F3456EEF1}" type="datetimeFigureOut">
               <a:rPr lang="pt-BR" smtClean="0"/>
-              <a:t>13/08/2026</a:t>
+              <a:t>17/08/2026</a:t>
             </a:fld>
             <a:endParaRPr lang="pt-BR"/>
           </a:p>
@@ -16101,7 +16101,7 @@
           <a:p>
             <a:fld id="{A87E3B6E-8316-4A1C-BADA-DB7F3456EEF1}" type="datetimeFigureOut">
               <a:rPr lang="pt-BR" smtClean="0"/>
-              <a:t>13/08/2026</a:t>
+              <a:t>17/08/2026</a:t>
             </a:fld>
             <a:endParaRPr lang="pt-BR"/>
           </a:p>
@@ -16342,7 +16342,7 @@
           <a:p>
             <a:fld id="{A87E3B6E-8316-4A1C-BADA-DB7F3456EEF1}" type="datetimeFigureOut">
               <a:rPr lang="pt-BR" smtClean="0"/>
-              <a:t>13/08/2026</a:t>
+              <a:t>17/08/2026</a:t>
             </a:fld>
             <a:endParaRPr lang="pt-BR"/>
           </a:p>
@@ -16906,7 +16906,7 @@
           <a:p>
             <a:fld id="{A87E3B6E-8316-4A1C-BADA-DB7F3456EEF1}" type="datetimeFigureOut">
               <a:rPr lang="pt-BR" smtClean="0"/>
-              <a:t>13/08/2026</a:t>
+              <a:t>17/08/2026</a:t>
             </a:fld>
             <a:endParaRPr lang="pt-BR"/>
           </a:p>

</xml_diff>

<commit_message>
Atualização de conteúdo LP
</commit_message>
<xml_diff>
--- a/UNIUBE-LP/Teoria_LP.pptx
+++ b/UNIUBE-LP/Teoria_LP.pptx
@@ -250,7 +250,7 @@
           <a:p>
             <a:fld id="{6ED03497-8374-466E-85FA-95E1138D8F6E}" type="datetimeFigureOut">
               <a:rPr lang="pt-BR" smtClean="0"/>
-              <a:t>17/08/2026</a:t>
+              <a:t>19/08/2026</a:t>
             </a:fld>
             <a:endParaRPr lang="pt-BR"/>
           </a:p>
@@ -11129,7 +11129,7 @@
           <a:p>
             <a:fld id="{A87E3B6E-8316-4A1C-BADA-DB7F3456EEF1}" type="datetimeFigureOut">
               <a:rPr lang="pt-BR" smtClean="0"/>
-              <a:t>17/08/2026</a:t>
+              <a:t>19/08/2026</a:t>
             </a:fld>
             <a:endParaRPr lang="pt-BR"/>
           </a:p>
@@ -11327,7 +11327,7 @@
           <a:p>
             <a:fld id="{A87E3B6E-8316-4A1C-BADA-DB7F3456EEF1}" type="datetimeFigureOut">
               <a:rPr lang="pt-BR" smtClean="0"/>
-              <a:t>17/08/2026</a:t>
+              <a:t>19/08/2026</a:t>
             </a:fld>
             <a:endParaRPr lang="pt-BR"/>
           </a:p>
@@ -11535,7 +11535,7 @@
           <a:p>
             <a:fld id="{A87E3B6E-8316-4A1C-BADA-DB7F3456EEF1}" type="datetimeFigureOut">
               <a:rPr lang="pt-BR" smtClean="0"/>
-              <a:t>17/08/2026</a:t>
+              <a:t>19/08/2026</a:t>
             </a:fld>
             <a:endParaRPr lang="pt-BR"/>
           </a:p>
@@ -11771,7 +11771,7 @@
           <a:p>
             <a:fld id="{A87E3B6E-8316-4A1C-BADA-DB7F3456EEF1}" type="datetimeFigureOut">
               <a:rPr lang="pt-BR" smtClean="0"/>
-              <a:t>17/08/2026</a:t>
+              <a:t>19/08/2026</a:t>
             </a:fld>
             <a:endParaRPr lang="pt-BR"/>
           </a:p>
@@ -11941,7 +11941,7 @@
           <a:p>
             <a:fld id="{A87E3B6E-8316-4A1C-BADA-DB7F3456EEF1}" type="datetimeFigureOut">
               <a:rPr lang="pt-BR" smtClean="0"/>
-              <a:t>17/08/2026</a:t>
+              <a:t>19/08/2026</a:t>
             </a:fld>
             <a:endParaRPr lang="pt-BR"/>
           </a:p>
@@ -12209,7 +12209,7 @@
           <a:p>
             <a:fld id="{A87E3B6E-8316-4A1C-BADA-DB7F3456EEF1}" type="datetimeFigureOut">
               <a:rPr lang="pt-BR" smtClean="0"/>
-              <a:t>17/08/2026</a:t>
+              <a:t>19/08/2026</a:t>
             </a:fld>
             <a:endParaRPr lang="pt-BR"/>
           </a:p>
@@ -12441,7 +12441,7 @@
           <a:p>
             <a:fld id="{A87E3B6E-8316-4A1C-BADA-DB7F3456EEF1}" type="datetimeFigureOut">
               <a:rPr lang="pt-BR" smtClean="0"/>
-              <a:t>17/08/2026</a:t>
+              <a:t>19/08/2026</a:t>
             </a:fld>
             <a:endParaRPr lang="pt-BR"/>
           </a:p>
@@ -12796,7 +12796,7 @@
           <a:p>
             <a:fld id="{A87E3B6E-8316-4A1C-BADA-DB7F3456EEF1}" type="datetimeFigureOut">
               <a:rPr lang="pt-BR" smtClean="0"/>
-              <a:t>17/08/2026</a:t>
+              <a:t>19/08/2026</a:t>
             </a:fld>
             <a:endParaRPr lang="pt-BR"/>
           </a:p>
@@ -12937,7 +12937,7 @@
           <a:p>
             <a:fld id="{A87E3B6E-8316-4A1C-BADA-DB7F3456EEF1}" type="datetimeFigureOut">
               <a:rPr lang="pt-BR" smtClean="0"/>
-              <a:t>17/08/2026</a:t>
+              <a:t>19/08/2026</a:t>
             </a:fld>
             <a:endParaRPr lang="pt-BR"/>
           </a:p>
@@ -13032,7 +13032,7 @@
           <a:p>
             <a:fld id="{A87E3B6E-8316-4A1C-BADA-DB7F3456EEF1}" type="datetimeFigureOut">
               <a:rPr lang="pt-BR" smtClean="0"/>
-              <a:t>17/08/2026</a:t>
+              <a:t>19/08/2026</a:t>
             </a:fld>
             <a:endParaRPr lang="pt-BR"/>
           </a:p>
@@ -13389,7 +13389,7 @@
           <a:p>
             <a:fld id="{A87E3B6E-8316-4A1C-BADA-DB7F3456EEF1}" type="datetimeFigureOut">
               <a:rPr lang="pt-BR" smtClean="0"/>
-              <a:t>17/08/2026</a:t>
+              <a:t>19/08/2026</a:t>
             </a:fld>
             <a:endParaRPr lang="pt-BR"/>
           </a:p>
@@ -13590,7 +13590,7 @@
           <a:p>
             <a:fld id="{A87E3B6E-8316-4A1C-BADA-DB7F3456EEF1}" type="datetimeFigureOut">
               <a:rPr lang="pt-BR" smtClean="0"/>
-              <a:t>17/08/2026</a:t>
+              <a:t>19/08/2026</a:t>
             </a:fld>
             <a:endParaRPr lang="pt-BR"/>
           </a:p>
@@ -13943,7 +13943,7 @@
           <a:p>
             <a:fld id="{A87E3B6E-8316-4A1C-BADA-DB7F3456EEF1}" type="datetimeFigureOut">
               <a:rPr lang="pt-BR" smtClean="0"/>
-              <a:t>17/08/2026</a:t>
+              <a:t>19/08/2026</a:t>
             </a:fld>
             <a:endParaRPr lang="pt-BR"/>
           </a:p>
@@ -14128,7 +14128,7 @@
           <a:p>
             <a:fld id="{A87E3B6E-8316-4A1C-BADA-DB7F3456EEF1}" type="datetimeFigureOut">
               <a:rPr lang="pt-BR" smtClean="0"/>
-              <a:t>17/08/2026</a:t>
+              <a:t>19/08/2026</a:t>
             </a:fld>
             <a:endParaRPr lang="pt-BR"/>
           </a:p>
@@ -14308,7 +14308,7 @@
           <a:p>
             <a:fld id="{A87E3B6E-8316-4A1C-BADA-DB7F3456EEF1}" type="datetimeFigureOut">
               <a:rPr lang="pt-BR" smtClean="0"/>
-              <a:t>17/08/2026</a:t>
+              <a:t>19/08/2026</a:t>
             </a:fld>
             <a:endParaRPr lang="pt-BR"/>
           </a:p>
@@ -14571,7 +14571,7 @@
           <a:p>
             <a:fld id="{A87E3B6E-8316-4A1C-BADA-DB7F3456EEF1}" type="datetimeFigureOut">
               <a:rPr lang="pt-BR" smtClean="0"/>
-              <a:t>17/08/2026</a:t>
+              <a:t>19/08/2026</a:t>
             </a:fld>
             <a:endParaRPr lang="pt-BR"/>
           </a:p>
@@ -14836,7 +14836,7 @@
           <a:p>
             <a:fld id="{A87E3B6E-8316-4A1C-BADA-DB7F3456EEF1}" type="datetimeFigureOut">
               <a:rPr lang="pt-BR" smtClean="0"/>
-              <a:t>17/08/2026</a:t>
+              <a:t>19/08/2026</a:t>
             </a:fld>
             <a:endParaRPr lang="pt-BR"/>
           </a:p>
@@ -15248,7 +15248,7 @@
           <a:p>
             <a:fld id="{A87E3B6E-8316-4A1C-BADA-DB7F3456EEF1}" type="datetimeFigureOut">
               <a:rPr lang="pt-BR" smtClean="0"/>
-              <a:t>17/08/2026</a:t>
+              <a:t>19/08/2026</a:t>
             </a:fld>
             <a:endParaRPr lang="pt-BR"/>
           </a:p>
@@ -15389,7 +15389,7 @@
           <a:p>
             <a:fld id="{A87E3B6E-8316-4A1C-BADA-DB7F3456EEF1}" type="datetimeFigureOut">
               <a:rPr lang="pt-BR" smtClean="0"/>
-              <a:t>17/08/2026</a:t>
+              <a:t>19/08/2026</a:t>
             </a:fld>
             <a:endParaRPr lang="pt-BR"/>
           </a:p>
@@ -15502,7 +15502,7 @@
           <a:p>
             <a:fld id="{A87E3B6E-8316-4A1C-BADA-DB7F3456EEF1}" type="datetimeFigureOut">
               <a:rPr lang="pt-BR" smtClean="0"/>
-              <a:t>17/08/2026</a:t>
+              <a:t>19/08/2026</a:t>
             </a:fld>
             <a:endParaRPr lang="pt-BR"/>
           </a:p>
@@ -15813,7 +15813,7 @@
           <a:p>
             <a:fld id="{A87E3B6E-8316-4A1C-BADA-DB7F3456EEF1}" type="datetimeFigureOut">
               <a:rPr lang="pt-BR" smtClean="0"/>
-              <a:t>17/08/2026</a:t>
+              <a:t>19/08/2026</a:t>
             </a:fld>
             <a:endParaRPr lang="pt-BR"/>
           </a:p>
@@ -16101,7 +16101,7 @@
           <a:p>
             <a:fld id="{A87E3B6E-8316-4A1C-BADA-DB7F3456EEF1}" type="datetimeFigureOut">
               <a:rPr lang="pt-BR" smtClean="0"/>
-              <a:t>17/08/2026</a:t>
+              <a:t>19/08/2026</a:t>
             </a:fld>
             <a:endParaRPr lang="pt-BR"/>
           </a:p>
@@ -16342,7 +16342,7 @@
           <a:p>
             <a:fld id="{A87E3B6E-8316-4A1C-BADA-DB7F3456EEF1}" type="datetimeFigureOut">
               <a:rPr lang="pt-BR" smtClean="0"/>
-              <a:t>17/08/2026</a:t>
+              <a:t>19/08/2026</a:t>
             </a:fld>
             <a:endParaRPr lang="pt-BR"/>
           </a:p>
@@ -16906,7 +16906,7 @@
           <a:p>
             <a:fld id="{A87E3B6E-8316-4A1C-BADA-DB7F3456EEF1}" type="datetimeFigureOut">
               <a:rPr lang="pt-BR" smtClean="0"/>
-              <a:t>17/08/2026</a:t>
+              <a:t>19/08/2026</a:t>
             </a:fld>
             <a:endParaRPr lang="pt-BR"/>
           </a:p>
@@ -27668,7 +27668,7 @@
               <a:t>Número real de dupla precisão (</a:t>
             </a:r>
             <a:r>
-              <a:rPr lang="pt-BR" sz="2200" dirty="0" err="1"/>
+              <a:rPr lang="pt-BR" sz="2200" i="1" dirty="0" err="1"/>
               <a:t>double</a:t>
             </a:r>
             <a:r>

</xml_diff>